<commit_message>
Actualiza Diagrama arquitectura de alto nivel Mentalia/FluyePro
</commit_message>
<xml_diff>
--- a/Diagramas/Arquitectura_Mentalia_FluyePro.pptx
+++ b/Diagramas/Arquitectura_Mentalia_FluyePro.pptx
@@ -4,15 +4,15 @@
   <p:sldMasterIdLst>
     <p:sldMasterId id="2147483648" r:id="rId1"/>
   </p:sldMasterIdLst>
+  <p:notesMasterIdLst>
+    <p:notesMasterId r:id="rId4"/>
+  </p:notesMasterIdLst>
   <p:sldIdLst>
     <p:sldId id="256" r:id="rId2"/>
     <p:sldId id="257" r:id="rId3"/>
   </p:sldIdLst>
-  <p:notesMasterIdLst>
-    <p:notesMasterId r:id="rId4"/>
-  </p:notesMasterIdLst>
-  <p:sldSz cx="12191695" cy="6858000"/>
-  <p:notesSz cx="6858000" cy="12191695"/>
+  <p:sldSz cx="12192000" cy="6858000"/>
+  <p:notesSz cx="6858000" cy="12192000"/>
   <p:defaultTextStyle>
     <a:lvl1pPr marL="0" algn="l" defTabSz="914400" rtl="0" eaLnBrk="1" latinLnBrk="0" hangingPunct="1">
       <a:defRPr sz="1800" kern="1200">
@@ -105,6 +105,11 @@
       </a:defRPr>
     </a:lvl9pPr>
   </p:defaultTextStyle>
+  <p:extLst>
+    <p:ext uri="{EFAFB233-063F-42B5-8137-9DF3F51BA10A}">
+      <p15:sldGuideLst xmlns:p15="http://schemas.microsoft.com/office/powerpoint/2012/main"/>
+    </p:ext>
+  </p:extLst>
 </p:presentation>
 </file>
 
@@ -130,234 +135,10 @@
           <a:chExt cx="0" cy="0"/>
         </a:xfrm>
       </p:grpSpPr>
-      <p:sp>
-        <p:nvSpPr>
-          <p:cNvPr id="2" name="Header Placeholder 1"/>
-          <p:cNvSpPr>
-            <a:spLocks noGrp="1"/>
-          </p:cNvSpPr>
-          <p:nvPr>
-            <p:ph type="hdr" sz="quarter"/>
-          </p:nvPr>
-        </p:nvSpPr>
-        <p:spPr>
-          <a:xfrm>
-            <a:off x="0" y="0"/>
-            <a:ext cx="2971800" cy="458788"/>
-          </a:xfrm>
-          <a:prstGeom prst="rect">
-            <a:avLst/>
-          </a:prstGeom>
-        </p:spPr>
-        <p:txBody>
-          <a:bodyPr vert="horz" lIns="91440" tIns="45720" rIns="91440" bIns="45720" rtlCol="0"/>
-          <a:lstStyle>
-            <a:lvl1pPr algn="l">
-              <a:defRPr sz="1200"/>
-            </a:lvl1pPr>
-          </a:lstStyle>
-          <a:p>
-            <a:endParaRPr lang="en-US"/>
-          </a:p>
-        </p:txBody>
-      </p:sp>
-      <p:sp>
-        <p:nvSpPr>
-          <p:cNvPr id="3" name="Date Placeholder 2"/>
-          <p:cNvSpPr>
-            <a:spLocks noGrp="1"/>
-          </p:cNvSpPr>
-          <p:nvPr>
-            <p:ph type="dt" idx="1"/>
-          </p:nvPr>
-        </p:nvSpPr>
-        <p:spPr>
-          <a:xfrm>
-            <a:off x="3884613" y="0"/>
-            <a:ext cx="2971800" cy="458788"/>
-          </a:xfrm>
-          <a:prstGeom prst="rect">
-            <a:avLst/>
-          </a:prstGeom>
-        </p:spPr>
-        <p:txBody>
-          <a:bodyPr vert="horz" lIns="91440" tIns="45720" rIns="91440" bIns="45720" rtlCol="0"/>
-          <a:lstStyle>
-            <a:lvl1pPr algn="r">
-              <a:defRPr sz="1200"/>
-            </a:lvl1pPr>
-          </a:lstStyle>
-          <a:p>
-            <a:fld id="{5282F153-3F37-0F45-9E97-73ACFA13230C}" type="datetimeFigureOut">
-              <a:rPr lang="en-US"/>
-              <a:t>7/23/19</a:t>
-            </a:fld>
-            <a:endParaRPr lang="en-US"/>
-          </a:p>
-        </p:txBody>
-      </p:sp>
-      <p:sp>
-        <p:nvSpPr>
-          <p:cNvPr id="4" name="Slide Image Placeholder 3"/>
-          <p:cNvSpPr>
-            <a:spLocks noGrp="1" noRot="1" noChangeAspect="1"/>
-          </p:cNvSpPr>
-          <p:nvPr>
-            <p:ph type="sldImg" idx="2"/>
-          </p:nvPr>
-        </p:nvSpPr>
-        <p:spPr>
-          <a:xfrm>
-            <a:off x="685800" y="1143000"/>
-            <a:ext cx="5486400" cy="3086100"/>
-          </a:xfrm>
-          <a:prstGeom prst="rect">
-            <a:avLst/>
-          </a:prstGeom>
-          <a:noFill/>
-          <a:ln w="12700">
-            <a:solidFill>
-              <a:prstClr val="black"/>
-            </a:solidFill>
-          </a:ln>
-        </p:spPr>
-        <p:txBody>
-          <a:bodyPr vert="horz" lIns="91440" tIns="45720" rIns="91440" bIns="45720" rtlCol="0" anchor="ctr"/>
-          <a:lstStyle/>
-          <a:p>
-            <a:endParaRPr lang="en-US"/>
-          </a:p>
-        </p:txBody>
-      </p:sp>
-      <p:sp>
-        <p:nvSpPr>
-          <p:cNvPr id="5" name="Notes Placeholder 4"/>
-          <p:cNvSpPr>
-            <a:spLocks noGrp="1"/>
-          </p:cNvSpPr>
-          <p:nvPr>
-            <p:ph type="body" sz="quarter" idx="3"/>
-          </p:nvPr>
-        </p:nvSpPr>
-        <p:spPr>
-          <a:xfrm>
-            <a:off x="685800" y="4400550"/>
-            <a:ext cx="5486400" cy="3600450"/>
-          </a:xfrm>
-          <a:prstGeom prst="rect">
-            <a:avLst/>
-          </a:prstGeom>
-        </p:spPr>
-        <p:txBody>
-          <a:bodyPr vert="horz" lIns="91440" tIns="45720" rIns="91440" bIns="45720" rtlCol="0"/>
-          <a:lstStyle/>
-          <a:p>
-            <a:pPr lvl="0"/>
-            <a:r>
-              <a:rPr lang="en-US"/>
-              <a:t>Click to edit Master text styles</a:t>
-            </a:r>
-          </a:p>
-          <a:p>
-            <a:pPr lvl="1"/>
-            <a:r>
-              <a:rPr lang="en-US"/>
-              <a:t>Second level</a:t>
-            </a:r>
-          </a:p>
-          <a:p>
-            <a:pPr lvl="2"/>
-            <a:r>
-              <a:rPr lang="en-US"/>
-              <a:t>Third level</a:t>
-            </a:r>
-          </a:p>
-          <a:p>
-            <a:pPr lvl="3"/>
-            <a:r>
-              <a:rPr lang="en-US"/>
-              <a:t>Fourth level</a:t>
-            </a:r>
-          </a:p>
-          <a:p>
-            <a:pPr lvl="4"/>
-            <a:r>
-              <a:rPr lang="en-US"/>
-              <a:t>Fifth level</a:t>
-            </a:r>
-          </a:p>
-        </p:txBody>
-      </p:sp>
-      <p:sp>
-        <p:nvSpPr>
-          <p:cNvPr id="6" name="Footer Placeholder 5"/>
-          <p:cNvSpPr>
-            <a:spLocks noGrp="1"/>
-          </p:cNvSpPr>
-          <p:nvPr>
-            <p:ph type="ftr" sz="quarter" idx="4"/>
-          </p:nvPr>
-        </p:nvSpPr>
-        <p:spPr>
-          <a:xfrm>
-            <a:off x="0" y="8685213"/>
-            <a:ext cx="2971800" cy="458787"/>
-          </a:xfrm>
-          <a:prstGeom prst="rect">
-            <a:avLst/>
-          </a:prstGeom>
-        </p:spPr>
-        <p:txBody>
-          <a:bodyPr vert="horz" lIns="91440" tIns="45720" rIns="91440" bIns="45720" rtlCol="0" anchor="b"/>
-          <a:lstStyle>
-            <a:lvl1pPr algn="l">
-              <a:defRPr sz="1200"/>
-            </a:lvl1pPr>
-          </a:lstStyle>
-          <a:p>
-            <a:endParaRPr lang="en-US"/>
-          </a:p>
-        </p:txBody>
-      </p:sp>
-      <p:sp>
-        <p:nvSpPr>
-          <p:cNvPr id="7" name="Slide Number Placeholder 6"/>
-          <p:cNvSpPr>
-            <a:spLocks noGrp="1"/>
-          </p:cNvSpPr>
-          <p:nvPr>
-            <p:ph type="sldNum" sz="quarter" idx="5"/>
-          </p:nvPr>
-        </p:nvSpPr>
-        <p:spPr>
-          <a:xfrm>
-            <a:off x="3884613" y="8685213"/>
-            <a:ext cx="2971800" cy="458787"/>
-          </a:xfrm>
-          <a:prstGeom prst="rect">
-            <a:avLst/>
-          </a:prstGeom>
-        </p:spPr>
-        <p:txBody>
-          <a:bodyPr vert="horz" lIns="91440" tIns="45720" rIns="91440" bIns="45720" rtlCol="0" anchor="b"/>
-          <a:lstStyle>
-            <a:lvl1pPr algn="r">
-              <a:defRPr sz="1200"/>
-            </a:lvl1pPr>
-          </a:lstStyle>
-          <a:p>
-            <a:fld id="{CE5E9CC1-C706-0F49-92D6-E571CC5EEA8F}" type="slidenum">
-              <a:rPr lang="en-US"/>
-              <a:t>‹#›</a:t>
-            </a:fld>
-            <a:endParaRPr lang="en-US"/>
-          </a:p>
-        </p:txBody>
-      </p:sp>
     </p:spTree>
     <p:extLst>
       <p:ext uri="{BB962C8B-B14F-4D97-AF65-F5344CB8AC3E}">
-        <p14:creationId xmlns:p14="http://schemas.microsoft.com/office/powerpoint/2010/main" val="1024086991"/>
+        <p14:creationId xmlns:p14="http://schemas.microsoft.com/office/powerpoint/2010/main" val="636087251"/>
       </p:ext>
     </p:extLst>
   </p:cSld>
@@ -501,10 +282,6 @@
           <a:bodyPr/>
           <a:lstStyle/>
           <a:p>
-            <a:r>
-              <a:rPr lang="en-US" dirty="0"/>
-              <a:t/>
-            </a:r>
             <a:endParaRPr lang="en-US" dirty="0"/>
           </a:p>
         </p:txBody>
@@ -589,10 +366,6 @@
           <a:bodyPr/>
           <a:lstStyle/>
           <a:p>
-            <a:r>
-              <a:rPr lang="en-US" dirty="0"/>
-              <a:t/>
-            </a:r>
             <a:endParaRPr lang="en-US" dirty="0"/>
           </a:p>
         </p:txBody>
@@ -666,6 +439,11 @@
 <file path=ppt/slideMasters/slideMaster1.xml><?xml version="1.0" encoding="utf-8"?>
 <p:sldMaster xmlns:a="http://schemas.openxmlformats.org/drawingml/2006/main" xmlns:r="http://schemas.openxmlformats.org/officeDocument/2006/relationships" xmlns:p="http://schemas.openxmlformats.org/presentationml/2006/main">
   <p:cSld>
+    <p:bg>
+      <p:bgRef idx="1001">
+        <a:schemeClr val="bg1"/>
+      </p:bgRef>
+    </p:bg>
     <p:spTree>
       <p:nvGrpSpPr>
         <p:cNvPr id="1" name=""/>
@@ -948,6 +726,7 @@
         <a:solidFill>
           <a:srgbClr val="F7FBFC"/>
         </a:solidFill>
+        <a:effectLst/>
       </p:bgPr>
     </p:bg>
     <p:spTree>
@@ -985,7 +764,7 @@
           <a:bodyPr wrap="square" lIns="0" tIns="0" rIns="0" bIns="0" rtlCol="0" anchor="ctr"/>
           <a:lstStyle/>
           <a:p>
-            <a:pPr indent="0" marL="0">
+            <a:pPr marL="0" indent="0">
               <a:buNone/>
             </a:pPr>
             <a:r>
@@ -1024,7 +803,7 @@
           <a:bodyPr wrap="square" lIns="0" tIns="0" rIns="0" bIns="0" rtlCol="0" anchor="ctr"/>
           <a:lstStyle/>
           <a:p>
-            <a:pPr indent="0" marL="0">
+            <a:pPr marL="0" indent="0">
               <a:buNone/>
             </a:pPr>
             <a:r>
@@ -1063,6 +842,13 @@
             <a:tailEnd type="triangle"/>
           </a:ln>
         </p:spPr>
+        <p:txBody>
+          <a:bodyPr/>
+          <a:lstStyle/>
+          <a:p>
+            <a:endParaRPr lang="es-CL"/>
+          </a:p>
+        </p:txBody>
       </p:sp>
       <p:sp>
         <p:nvSpPr>
@@ -1088,6 +874,13 @@
             <a:tailEnd type="triangle"/>
           </a:ln>
         </p:spPr>
+        <p:txBody>
+          <a:bodyPr/>
+          <a:lstStyle/>
+          <a:p>
+            <a:endParaRPr lang="es-CL"/>
+          </a:p>
+        </p:txBody>
       </p:sp>
       <p:sp>
         <p:nvSpPr>
@@ -1113,6 +906,13 @@
             <a:tailEnd type="triangle"/>
           </a:ln>
         </p:spPr>
+        <p:txBody>
+          <a:bodyPr/>
+          <a:lstStyle/>
+          <a:p>
+            <a:endParaRPr lang="es-CL"/>
+          </a:p>
+        </p:txBody>
       </p:sp>
       <p:sp>
         <p:nvSpPr>
@@ -1138,6 +938,13 @@
             <a:tailEnd type="triangle"/>
           </a:ln>
         </p:spPr>
+        <p:txBody>
+          <a:bodyPr/>
+          <a:lstStyle/>
+          <a:p>
+            <a:endParaRPr lang="es-CL"/>
+          </a:p>
+        </p:txBody>
       </p:sp>
       <p:sp>
         <p:nvSpPr>
@@ -1163,6 +970,13 @@
             <a:tailEnd type="triangle"/>
           </a:ln>
         </p:spPr>
+        <p:txBody>
+          <a:bodyPr/>
+          <a:lstStyle/>
+          <a:p>
+            <a:endParaRPr lang="es-CL"/>
+          </a:p>
+        </p:txBody>
       </p:sp>
       <p:sp>
         <p:nvSpPr>
@@ -1188,6 +1002,13 @@
             <a:tailEnd type="triangle"/>
           </a:ln>
         </p:spPr>
+        <p:txBody>
+          <a:bodyPr/>
+          <a:lstStyle/>
+          <a:p>
+            <a:endParaRPr lang="es-CL"/>
+          </a:p>
+        </p:txBody>
       </p:sp>
       <p:sp>
         <p:nvSpPr>
@@ -1213,6 +1034,13 @@
             <a:tailEnd type="triangle"/>
           </a:ln>
         </p:spPr>
+        <p:txBody>
+          <a:bodyPr/>
+          <a:lstStyle/>
+          <a:p>
+            <a:endParaRPr lang="es-CL"/>
+          </a:p>
+        </p:txBody>
       </p:sp>
       <p:sp>
         <p:nvSpPr>
@@ -1238,6 +1066,13 @@
             <a:tailEnd type="triangle"/>
           </a:ln>
         </p:spPr>
+        <p:txBody>
+          <a:bodyPr/>
+          <a:lstStyle/>
+          <a:p>
+            <a:endParaRPr lang="es-CL"/>
+          </a:p>
+        </p:txBody>
       </p:sp>
       <p:sp>
         <p:nvSpPr>
@@ -1263,6 +1098,13 @@
             <a:tailEnd type="triangle"/>
           </a:ln>
         </p:spPr>
+        <p:txBody>
+          <a:bodyPr/>
+          <a:lstStyle/>
+          <a:p>
+            <a:endParaRPr lang="es-CL"/>
+          </a:p>
+        </p:txBody>
       </p:sp>
       <p:sp>
         <p:nvSpPr>
@@ -1288,6 +1130,13 @@
             <a:tailEnd type="triangle"/>
           </a:ln>
         </p:spPr>
+        <p:txBody>
+          <a:bodyPr/>
+          <a:lstStyle/>
+          <a:p>
+            <a:endParaRPr lang="es-CL"/>
+          </a:p>
+        </p:txBody>
       </p:sp>
       <p:sp>
         <p:nvSpPr>
@@ -1313,6 +1162,13 @@
             <a:tailEnd type="triangle"/>
           </a:ln>
         </p:spPr>
+        <p:txBody>
+          <a:bodyPr/>
+          <a:lstStyle/>
+          <a:p>
+            <a:endParaRPr lang="es-CL"/>
+          </a:p>
+        </p:txBody>
       </p:sp>
       <p:sp>
         <p:nvSpPr>
@@ -1340,13 +1196,20 @@
             <a:prstDash val="solid"/>
           </a:ln>
           <a:effectLst>
-            <a:outerShdw sx="100000" sy="100000" kx="0" ky="0" algn="bl" rotWithShape="0" blurRad="12700" dist="50800" dir="2700000">
+            <a:outerShdw blurRad="12700" dist="50800" dir="2700000" algn="bl" rotWithShape="0">
               <a:srgbClr val="D5DEE7">
                 <a:alpha val="24000"/>
               </a:srgbClr>
             </a:outerShdw>
           </a:effectLst>
         </p:spPr>
+        <p:txBody>
+          <a:bodyPr/>
+          <a:lstStyle/>
+          <a:p>
+            <a:endParaRPr lang="es-CL"/>
+          </a:p>
+        </p:txBody>
       </p:sp>
       <p:sp>
         <p:nvSpPr>
@@ -1371,7 +1234,7 @@
           </a:bodyPr>
           <a:lstStyle/>
           <a:p>
-            <a:pPr algn="ctr" indent="0" marL="0">
+            <a:pPr marL="0" indent="0" algn="ctr">
               <a:buNone/>
             </a:pPr>
             <a:r>
@@ -1412,6 +1275,13 @@
             <a:prstDash val="solid"/>
           </a:ln>
         </p:spPr>
+        <p:txBody>
+          <a:bodyPr/>
+          <a:lstStyle/>
+          <a:p>
+            <a:endParaRPr lang="es-CL"/>
+          </a:p>
+        </p:txBody>
       </p:sp>
       <p:sp>
         <p:nvSpPr>
@@ -1434,7 +1304,7 @@
           <a:bodyPr wrap="square" lIns="0" tIns="0" rIns="0" bIns="0" rtlCol="0" anchor="ctr"/>
           <a:lstStyle/>
           <a:p>
-            <a:pPr algn="ctr" indent="0" marL="0">
+            <a:pPr marL="0" indent="0" algn="ctr">
               <a:buNone/>
             </a:pPr>
             <a:r>
@@ -1475,6 +1345,13 @@
             <a:prstDash val="solid"/>
           </a:ln>
         </p:spPr>
+        <p:txBody>
+          <a:bodyPr/>
+          <a:lstStyle/>
+          <a:p>
+            <a:endParaRPr lang="es-CL"/>
+          </a:p>
+        </p:txBody>
       </p:sp>
       <p:sp>
         <p:nvSpPr>
@@ -1497,7 +1374,7 @@
           <a:bodyPr wrap="square" lIns="0" tIns="0" rIns="0" bIns="0" rtlCol="0" anchor="ctr"/>
           <a:lstStyle/>
           <a:p>
-            <a:pPr algn="ctr" indent="0" marL="0">
+            <a:pPr marL="0" indent="0" algn="ctr">
               <a:buNone/>
             </a:pPr>
             <a:r>
@@ -1538,6 +1415,13 @@
             <a:prstDash val="solid"/>
           </a:ln>
         </p:spPr>
+        <p:txBody>
+          <a:bodyPr/>
+          <a:lstStyle/>
+          <a:p>
+            <a:endParaRPr lang="es-CL"/>
+          </a:p>
+        </p:txBody>
       </p:sp>
       <p:sp>
         <p:nvSpPr>
@@ -1560,7 +1444,7 @@
           <a:bodyPr wrap="square" lIns="0" tIns="0" rIns="0" bIns="0" rtlCol="0" anchor="ctr"/>
           <a:lstStyle/>
           <a:p>
-            <a:pPr algn="ctr" indent="0" marL="0">
+            <a:pPr marL="0" indent="0" algn="ctr">
               <a:buNone/>
             </a:pPr>
             <a:r>
@@ -1601,6 +1485,13 @@
             <a:prstDash val="solid"/>
           </a:ln>
         </p:spPr>
+        <p:txBody>
+          <a:bodyPr/>
+          <a:lstStyle/>
+          <a:p>
+            <a:endParaRPr lang="es-CL"/>
+          </a:p>
+        </p:txBody>
       </p:sp>
       <p:sp>
         <p:nvSpPr>
@@ -1623,7 +1514,7 @@
           <a:bodyPr wrap="square" lIns="0" tIns="0" rIns="0" bIns="0" rtlCol="0" anchor="ctr"/>
           <a:lstStyle/>
           <a:p>
-            <a:pPr algn="ctr" indent="0" marL="0">
+            <a:pPr marL="0" indent="0" algn="ctr">
               <a:buNone/>
             </a:pPr>
             <a:r>
@@ -1664,6 +1555,13 @@
             <a:prstDash val="solid"/>
           </a:ln>
         </p:spPr>
+        <p:txBody>
+          <a:bodyPr/>
+          <a:lstStyle/>
+          <a:p>
+            <a:endParaRPr lang="es-CL"/>
+          </a:p>
+        </p:txBody>
       </p:sp>
       <p:sp>
         <p:nvSpPr>
@@ -1686,7 +1584,7 @@
           <a:bodyPr wrap="square" lIns="0" tIns="0" rIns="0" bIns="0" rtlCol="0" anchor="ctr"/>
           <a:lstStyle/>
           <a:p>
-            <a:pPr algn="ctr" indent="0" marL="0">
+            <a:pPr marL="0" indent="0" algn="ctr">
               <a:buNone/>
             </a:pPr>
             <a:r>
@@ -1727,13 +1625,20 @@
             <a:prstDash val="solid"/>
           </a:ln>
           <a:effectLst>
-            <a:outerShdw sx="100000" sy="100000" kx="0" ky="0" algn="bl" rotWithShape="0" blurRad="12700" dist="50800" dir="2700000">
+            <a:outerShdw blurRad="12700" dist="50800" dir="2700000" algn="bl" rotWithShape="0">
               <a:srgbClr val="D5DEE7">
                 <a:alpha val="24000"/>
               </a:srgbClr>
             </a:outerShdw>
           </a:effectLst>
         </p:spPr>
+        <p:txBody>
+          <a:bodyPr/>
+          <a:lstStyle/>
+          <a:p>
+            <a:endParaRPr lang="es-CL"/>
+          </a:p>
+        </p:txBody>
       </p:sp>
       <p:sp>
         <p:nvSpPr>
@@ -1758,7 +1663,7 @@
           </a:bodyPr>
           <a:lstStyle/>
           <a:p>
-            <a:pPr algn="ctr" indent="0" marL="0">
+            <a:pPr marL="0" indent="0" algn="ctr">
               <a:buNone/>
             </a:pPr>
             <a:r>
@@ -1772,7 +1677,7 @@
             <a:endParaRPr lang="en-US" sz="1050" dirty="0"/>
           </a:p>
           <a:p>
-            <a:pPr algn="ctr" indent="0" marL="0">
+            <a:pPr marL="0" indent="0" algn="ctr">
               <a:buNone/>
             </a:pPr>
             <a:r>
@@ -1813,13 +1718,20 @@
             <a:prstDash val="solid"/>
           </a:ln>
           <a:effectLst>
-            <a:outerShdw sx="100000" sy="100000" kx="0" ky="0" algn="bl" rotWithShape="0" blurRad="12700" dist="50800" dir="2700000">
+            <a:outerShdw blurRad="12700" dist="50800" dir="2700000" algn="bl" rotWithShape="0">
               <a:srgbClr val="D5DEE7">
                 <a:alpha val="24000"/>
               </a:srgbClr>
             </a:outerShdw>
           </a:effectLst>
         </p:spPr>
+        <p:txBody>
+          <a:bodyPr/>
+          <a:lstStyle/>
+          <a:p>
+            <a:endParaRPr lang="es-CL"/>
+          </a:p>
+        </p:txBody>
       </p:sp>
       <p:sp>
         <p:nvSpPr>
@@ -1844,7 +1756,7 @@
           </a:bodyPr>
           <a:lstStyle/>
           <a:p>
-            <a:pPr algn="ctr" indent="0" marL="0">
+            <a:pPr marL="0" indent="0" algn="ctr">
               <a:buNone/>
             </a:pPr>
             <a:r>
@@ -1858,7 +1770,7 @@
             <a:endParaRPr lang="en-US" sz="1050" dirty="0"/>
           </a:p>
           <a:p>
-            <a:pPr algn="ctr" indent="0" marL="0">
+            <a:pPr marL="0" indent="0" algn="ctr">
               <a:buNone/>
             </a:pPr>
             <a:r>
@@ -1899,6 +1811,13 @@
             <a:prstDash val="solid"/>
           </a:ln>
         </p:spPr>
+        <p:txBody>
+          <a:bodyPr/>
+          <a:lstStyle/>
+          <a:p>
+            <a:endParaRPr lang="es-CL"/>
+          </a:p>
+        </p:txBody>
       </p:sp>
       <p:sp>
         <p:nvSpPr>
@@ -1923,7 +1842,7 @@
           </a:bodyPr>
           <a:lstStyle/>
           <a:p>
-            <a:pPr algn="ctr" indent="0" marL="0">
+            <a:pPr marL="0" indent="0" algn="ctr">
               <a:buNone/>
             </a:pPr>
             <a:r>
@@ -1937,7 +1856,7 @@
             <a:endParaRPr lang="en-US" sz="1050" dirty="0"/>
           </a:p>
           <a:p>
-            <a:pPr algn="ctr" indent="0" marL="0">
+            <a:pPr marL="0" indent="0" algn="ctr">
               <a:buNone/>
             </a:pPr>
             <a:r>
@@ -1978,13 +1897,20 @@
             <a:prstDash val="solid"/>
           </a:ln>
           <a:effectLst>
-            <a:outerShdw sx="100000" sy="100000" kx="0" ky="0" algn="bl" rotWithShape="0" blurRad="12700" dist="50800" dir="2700000">
+            <a:outerShdw blurRad="12700" dist="50800" dir="2700000" algn="bl" rotWithShape="0">
               <a:srgbClr val="D5DEE7">
                 <a:alpha val="24000"/>
               </a:srgbClr>
             </a:outerShdw>
           </a:effectLst>
         </p:spPr>
+        <p:txBody>
+          <a:bodyPr/>
+          <a:lstStyle/>
+          <a:p>
+            <a:endParaRPr lang="es-CL"/>
+          </a:p>
+        </p:txBody>
       </p:sp>
       <p:sp>
         <p:nvSpPr>
@@ -2009,7 +1935,7 @@
           </a:bodyPr>
           <a:lstStyle/>
           <a:p>
-            <a:pPr algn="ctr" indent="0" marL="0">
+            <a:pPr marL="0" indent="0" algn="ctr">
               <a:buNone/>
             </a:pPr>
             <a:r>
@@ -2023,7 +1949,7 @@
             <a:endParaRPr lang="en-US" sz="1050" dirty="0"/>
           </a:p>
           <a:p>
-            <a:pPr algn="ctr" indent="0" marL="0">
+            <a:pPr marL="0" indent="0" algn="ctr">
               <a:buNone/>
             </a:pPr>
             <a:r>
@@ -2064,6 +1990,13 @@
             <a:prstDash val="solid"/>
           </a:ln>
         </p:spPr>
+        <p:txBody>
+          <a:bodyPr/>
+          <a:lstStyle/>
+          <a:p>
+            <a:endParaRPr lang="es-CL"/>
+          </a:p>
+        </p:txBody>
       </p:sp>
       <p:sp>
         <p:nvSpPr>
@@ -2088,7 +2021,7 @@
           </a:bodyPr>
           <a:lstStyle/>
           <a:p>
-            <a:pPr algn="ctr" indent="0" marL="0">
+            <a:pPr marL="0" indent="0" algn="ctr">
               <a:buNone/>
             </a:pPr>
             <a:r>
@@ -2102,7 +2035,7 @@
             <a:endParaRPr lang="en-US" sz="1050" dirty="0"/>
           </a:p>
           <a:p>
-            <a:pPr algn="ctr" indent="0" marL="0">
+            <a:pPr marL="0" indent="0" algn="ctr">
               <a:buNone/>
             </a:pPr>
             <a:r>
@@ -2143,6 +2076,13 @@
             <a:prstDash val="solid"/>
           </a:ln>
         </p:spPr>
+        <p:txBody>
+          <a:bodyPr/>
+          <a:lstStyle/>
+          <a:p>
+            <a:endParaRPr lang="es-CL"/>
+          </a:p>
+        </p:txBody>
       </p:sp>
       <p:sp>
         <p:nvSpPr>
@@ -2167,7 +2107,7 @@
           </a:bodyPr>
           <a:lstStyle/>
           <a:p>
-            <a:pPr algn="ctr" indent="0" marL="0">
+            <a:pPr marL="0" indent="0" algn="ctr">
               <a:buNone/>
             </a:pPr>
             <a:r>
@@ -2181,7 +2121,7 @@
             <a:endParaRPr lang="en-US" sz="1000" dirty="0"/>
           </a:p>
           <a:p>
-            <a:pPr algn="ctr" indent="0" marL="0">
+            <a:pPr marL="0" indent="0" algn="ctr">
               <a:buNone/>
             </a:pPr>
             <a:r>
@@ -2222,13 +2162,20 @@
             <a:prstDash val="solid"/>
           </a:ln>
           <a:effectLst>
-            <a:outerShdw sx="100000" sy="100000" kx="0" ky="0" algn="bl" rotWithShape="0" blurRad="12700" dist="50800" dir="2700000">
+            <a:outerShdw blurRad="12700" dist="50800" dir="2700000" algn="bl" rotWithShape="0">
               <a:srgbClr val="D5DEE7">
                 <a:alpha val="24000"/>
               </a:srgbClr>
             </a:outerShdw>
           </a:effectLst>
         </p:spPr>
+        <p:txBody>
+          <a:bodyPr/>
+          <a:lstStyle/>
+          <a:p>
+            <a:endParaRPr lang="es-CL"/>
+          </a:p>
+        </p:txBody>
       </p:sp>
       <p:sp>
         <p:nvSpPr>
@@ -2253,7 +2200,7 @@
           </a:bodyPr>
           <a:lstStyle/>
           <a:p>
-            <a:pPr algn="ctr" indent="0" marL="0">
+            <a:pPr marL="0" indent="0" algn="ctr">
               <a:buNone/>
             </a:pPr>
             <a:r>
@@ -2267,7 +2214,7 @@
             <a:endParaRPr lang="en-US" sz="1050" dirty="0"/>
           </a:p>
           <a:p>
-            <a:pPr algn="ctr" indent="0" marL="0">
+            <a:pPr marL="0" indent="0" algn="ctr">
               <a:buNone/>
             </a:pPr>
             <a:r>
@@ -2308,13 +2255,20 @@
             <a:prstDash val="solid"/>
           </a:ln>
           <a:effectLst>
-            <a:outerShdw sx="100000" sy="100000" kx="0" ky="0" algn="bl" rotWithShape="0" blurRad="12700" dist="50800" dir="2700000">
+            <a:outerShdw blurRad="12700" dist="50800" dir="2700000" algn="bl" rotWithShape="0">
               <a:srgbClr val="D5DEE7">
                 <a:alpha val="24000"/>
               </a:srgbClr>
             </a:outerShdw>
           </a:effectLst>
         </p:spPr>
+        <p:txBody>
+          <a:bodyPr/>
+          <a:lstStyle/>
+          <a:p>
+            <a:endParaRPr lang="es-CL"/>
+          </a:p>
+        </p:txBody>
       </p:sp>
       <p:sp>
         <p:nvSpPr>
@@ -2339,7 +2293,7 @@
           </a:bodyPr>
           <a:lstStyle/>
           <a:p>
-            <a:pPr algn="ctr" indent="0" marL="0">
+            <a:pPr marL="0" indent="0" algn="ctr">
               <a:buNone/>
             </a:pPr>
             <a:r>
@@ -2353,7 +2307,7 @@
             <a:endParaRPr lang="en-US" sz="1020" dirty="0"/>
           </a:p>
           <a:p>
-            <a:pPr algn="ctr" indent="0" marL="0">
+            <a:pPr marL="0" indent="0" algn="ctr">
               <a:buNone/>
             </a:pPr>
             <a:r>
@@ -2394,6 +2348,13 @@
             <a:prstDash val="solid"/>
           </a:ln>
         </p:spPr>
+        <p:txBody>
+          <a:bodyPr/>
+          <a:lstStyle/>
+          <a:p>
+            <a:endParaRPr lang="es-CL"/>
+          </a:p>
+        </p:txBody>
       </p:sp>
       <p:sp>
         <p:nvSpPr>
@@ -2418,7 +2379,7 @@
           </a:bodyPr>
           <a:lstStyle/>
           <a:p>
-            <a:pPr algn="ctr" indent="0" marL="0">
+            <a:pPr marL="0" indent="0" algn="ctr">
               <a:buNone/>
             </a:pPr>
             <a:r>
@@ -2432,7 +2393,7 @@
             <a:endParaRPr lang="en-US" sz="1020" dirty="0"/>
           </a:p>
           <a:p>
-            <a:pPr algn="ctr" indent="0" marL="0">
+            <a:pPr marL="0" indent="0" algn="ctr">
               <a:buNone/>
             </a:pPr>
             <a:r>
@@ -2473,6 +2434,13 @@
             <a:prstDash val="solid"/>
           </a:ln>
         </p:spPr>
+        <p:txBody>
+          <a:bodyPr/>
+          <a:lstStyle/>
+          <a:p>
+            <a:endParaRPr lang="es-CL"/>
+          </a:p>
+        </p:txBody>
       </p:sp>
       <p:sp>
         <p:nvSpPr>
@@ -2497,7 +2465,7 @@
           </a:bodyPr>
           <a:lstStyle/>
           <a:p>
-            <a:pPr algn="ctr" indent="0" marL="0">
+            <a:pPr marL="0" indent="0" algn="ctr">
               <a:buNone/>
             </a:pPr>
             <a:r>
@@ -2511,7 +2479,7 @@
             <a:endParaRPr lang="en-US" sz="960" dirty="0"/>
           </a:p>
           <a:p>
-            <a:pPr algn="ctr" indent="0" marL="0">
+            <a:pPr marL="0" indent="0" algn="ctr">
               <a:buNone/>
             </a:pPr>
             <a:r>
@@ -2552,13 +2520,20 @@
             <a:prstDash val="solid"/>
           </a:ln>
           <a:effectLst>
-            <a:outerShdw sx="100000" sy="100000" kx="0" ky="0" algn="bl" rotWithShape="0" blurRad="12700" dist="50800" dir="2700000">
+            <a:outerShdw blurRad="12700" dist="50800" dir="2700000" algn="bl" rotWithShape="0">
               <a:srgbClr val="D5DEE7">
                 <a:alpha val="24000"/>
               </a:srgbClr>
             </a:outerShdw>
           </a:effectLst>
         </p:spPr>
+        <p:txBody>
+          <a:bodyPr/>
+          <a:lstStyle/>
+          <a:p>
+            <a:endParaRPr lang="es-CL"/>
+          </a:p>
+        </p:txBody>
       </p:sp>
       <p:sp>
         <p:nvSpPr>
@@ -2583,7 +2558,7 @@
           </a:bodyPr>
           <a:lstStyle/>
           <a:p>
-            <a:pPr algn="ctr" indent="0" marL="0">
+            <a:pPr marL="0" indent="0" algn="ctr">
               <a:buNone/>
             </a:pPr>
             <a:r>
@@ -2597,7 +2572,7 @@
             <a:endParaRPr lang="en-US" sz="1020" dirty="0"/>
           </a:p>
           <a:p>
-            <a:pPr algn="ctr" indent="0" marL="0">
+            <a:pPr marL="0" indent="0" algn="ctr">
               <a:buNone/>
             </a:pPr>
             <a:r>
@@ -2638,6 +2613,13 @@
             <a:prstDash val="solid"/>
           </a:ln>
         </p:spPr>
+        <p:txBody>
+          <a:bodyPr/>
+          <a:lstStyle/>
+          <a:p>
+            <a:endParaRPr lang="es-CL"/>
+          </a:p>
+        </p:txBody>
       </p:sp>
       <p:sp>
         <p:nvSpPr>
@@ -2662,7 +2644,7 @@
           </a:bodyPr>
           <a:lstStyle/>
           <a:p>
-            <a:pPr algn="ctr" indent="0" marL="0">
+            <a:pPr marL="0" indent="0" algn="ctr">
               <a:buNone/>
             </a:pPr>
             <a:r>
@@ -2676,7 +2658,7 @@
             <a:endParaRPr lang="en-US" sz="1020" dirty="0"/>
           </a:p>
           <a:p>
-            <a:pPr algn="ctr" indent="0" marL="0">
+            <a:pPr marL="0" indent="0" algn="ctr">
               <a:buNone/>
             </a:pPr>
             <a:r>
@@ -2717,6 +2699,13 @@
             <a:prstDash val="solid"/>
           </a:ln>
         </p:spPr>
+        <p:txBody>
+          <a:bodyPr/>
+          <a:lstStyle/>
+          <a:p>
+            <a:endParaRPr lang="es-CL"/>
+          </a:p>
+        </p:txBody>
       </p:sp>
       <p:sp>
         <p:nvSpPr>
@@ -2741,7 +2730,7 @@
           </a:bodyPr>
           <a:lstStyle/>
           <a:p>
-            <a:pPr algn="ctr" indent="0" marL="0">
+            <a:pPr marL="0" indent="0" algn="ctr">
               <a:buNone/>
             </a:pPr>
             <a:r>
@@ -2755,7 +2744,7 @@
             <a:endParaRPr lang="en-US" sz="1020" dirty="0"/>
           </a:p>
           <a:p>
-            <a:pPr algn="ctr" indent="0" marL="0">
+            <a:pPr marL="0" indent="0" algn="ctr">
               <a:buNone/>
             </a:pPr>
             <a:r>
@@ -2796,6 +2785,13 @@
             <a:prstDash val="solid"/>
           </a:ln>
         </p:spPr>
+        <p:txBody>
+          <a:bodyPr/>
+          <a:lstStyle/>
+          <a:p>
+            <a:endParaRPr lang="es-CL"/>
+          </a:p>
+        </p:txBody>
       </p:sp>
       <p:sp>
         <p:nvSpPr>
@@ -2820,7 +2816,7 @@
           </a:bodyPr>
           <a:lstStyle/>
           <a:p>
-            <a:pPr algn="ctr" indent="0" marL="0">
+            <a:pPr marL="0" indent="0" algn="ctr">
               <a:buNone/>
             </a:pPr>
             <a:r>
@@ -2834,7 +2830,7 @@
             <a:endParaRPr lang="en-US" sz="960" dirty="0"/>
           </a:p>
           <a:p>
-            <a:pPr algn="ctr" indent="0" marL="0">
+            <a:pPr marL="0" indent="0" algn="ctr">
               <a:buNone/>
             </a:pPr>
             <a:r>
@@ -2875,13 +2871,20 @@
             <a:prstDash val="solid"/>
           </a:ln>
           <a:effectLst>
-            <a:outerShdw sx="100000" sy="100000" kx="0" ky="0" algn="bl" rotWithShape="0" blurRad="12700" dist="50800" dir="2700000">
+            <a:outerShdw blurRad="12700" dist="50800" dir="2700000" algn="bl" rotWithShape="0">
               <a:srgbClr val="D5DEE7">
                 <a:alpha val="24000"/>
               </a:srgbClr>
             </a:outerShdw>
           </a:effectLst>
         </p:spPr>
+        <p:txBody>
+          <a:bodyPr/>
+          <a:lstStyle/>
+          <a:p>
+            <a:endParaRPr lang="es-CL"/>
+          </a:p>
+        </p:txBody>
       </p:sp>
       <p:sp>
         <p:nvSpPr>
@@ -2906,7 +2909,7 @@
           </a:bodyPr>
           <a:lstStyle/>
           <a:p>
-            <a:pPr algn="ctr" indent="0" marL="0">
+            <a:pPr marL="0" indent="0" algn="ctr">
               <a:buNone/>
             </a:pPr>
             <a:r>
@@ -2920,7 +2923,7 @@
             <a:endParaRPr lang="en-US" sz="970" dirty="0"/>
           </a:p>
           <a:p>
-            <a:pPr algn="ctr" indent="0" marL="0">
+            <a:pPr marL="0" indent="0" algn="ctr">
               <a:buNone/>
             </a:pPr>
             <a:r>
@@ -2961,6 +2964,13 @@
             <a:prstDash val="solid"/>
           </a:ln>
         </p:spPr>
+        <p:txBody>
+          <a:bodyPr/>
+          <a:lstStyle/>
+          <a:p>
+            <a:endParaRPr lang="es-CL"/>
+          </a:p>
+        </p:txBody>
       </p:sp>
       <p:sp>
         <p:nvSpPr>
@@ -2985,7 +2995,7 @@
           </a:bodyPr>
           <a:lstStyle/>
           <a:p>
-            <a:pPr algn="ctr" indent="0" marL="0">
+            <a:pPr marL="0" indent="0" algn="ctr">
               <a:buNone/>
             </a:pPr>
             <a:r>
@@ -2999,7 +3009,7 @@
             <a:endParaRPr lang="en-US" sz="950" dirty="0"/>
           </a:p>
           <a:p>
-            <a:pPr algn="ctr" indent="0" marL="0">
+            <a:pPr marL="0" indent="0" algn="ctr">
               <a:buNone/>
             </a:pPr>
             <a:r>
@@ -3040,6 +3050,13 @@
             <a:prstDash val="solid"/>
           </a:ln>
         </p:spPr>
+        <p:txBody>
+          <a:bodyPr/>
+          <a:lstStyle/>
+          <a:p>
+            <a:endParaRPr lang="es-CL"/>
+          </a:p>
+        </p:txBody>
       </p:sp>
       <p:sp>
         <p:nvSpPr>
@@ -3064,7 +3081,7 @@
           </a:bodyPr>
           <a:lstStyle/>
           <a:p>
-            <a:pPr algn="ctr" indent="0" marL="0">
+            <a:pPr marL="0" indent="0" algn="ctr">
               <a:buNone/>
             </a:pPr>
             <a:r>
@@ -3078,7 +3095,7 @@
             <a:endParaRPr lang="en-US" sz="950" dirty="0"/>
           </a:p>
           <a:p>
-            <a:pPr algn="ctr" indent="0" marL="0">
+            <a:pPr marL="0" indent="0" algn="ctr">
               <a:buNone/>
             </a:pPr>
             <a:r>
@@ -3119,6 +3136,13 @@
             <a:prstDash val="solid"/>
           </a:ln>
         </p:spPr>
+        <p:txBody>
+          <a:bodyPr/>
+          <a:lstStyle/>
+          <a:p>
+            <a:endParaRPr lang="es-CL"/>
+          </a:p>
+        </p:txBody>
       </p:sp>
       <p:sp>
         <p:nvSpPr>
@@ -3143,7 +3167,7 @@
           </a:bodyPr>
           <a:lstStyle/>
           <a:p>
-            <a:pPr algn="ctr" indent="0" marL="0">
+            <a:pPr marL="0" indent="0" algn="ctr">
               <a:buNone/>
             </a:pPr>
             <a:r>
@@ -3153,20 +3177,6 @@
                 </a:solidFill>
               </a:rPr>
               <a:t>Calendario / WhatsApp</a:t>
-            </a:r>
-            <a:endParaRPr lang="en-US" sz="950" dirty="0"/>
-          </a:p>
-          <a:p>
-            <a:pPr algn="ctr" indent="0" marL="0">
-              <a:buNone/>
-            </a:pPr>
-            <a:r>
-              <a:rPr lang="en-US" sz="950" dirty="0">
-                <a:solidFill>
-                  <a:srgbClr val="18324A"/>
-                </a:solidFill>
-              </a:rPr>
-              <a:t>futuro</a:t>
             </a:r>
             <a:endParaRPr lang="en-US" sz="950" dirty="0"/>
           </a:p>
@@ -3198,6 +3208,13 @@
             <a:prstDash val="solid"/>
           </a:ln>
         </p:spPr>
+        <p:txBody>
+          <a:bodyPr/>
+          <a:lstStyle/>
+          <a:p>
+            <a:endParaRPr lang="es-CL"/>
+          </a:p>
+        </p:txBody>
       </p:sp>
       <p:sp>
         <p:nvSpPr>
@@ -3222,7 +3239,7 @@
           </a:bodyPr>
           <a:lstStyle/>
           <a:p>
-            <a:pPr algn="ctr" indent="0" marL="0">
+            <a:pPr marL="0" indent="0" algn="ctr">
               <a:buNone/>
             </a:pPr>
             <a:r>
@@ -3263,6 +3280,13 @@
             <a:prstDash val="solid"/>
           </a:ln>
         </p:spPr>
+        <p:txBody>
+          <a:bodyPr/>
+          <a:lstStyle/>
+          <a:p>
+            <a:endParaRPr lang="es-CL"/>
+          </a:p>
+        </p:txBody>
       </p:sp>
       <p:sp>
         <p:nvSpPr>
@@ -3287,7 +3311,7 @@
           </a:bodyPr>
           <a:lstStyle/>
           <a:p>
-            <a:pPr algn="ctr" indent="0" marL="0">
+            <a:pPr marL="0" indent="0" algn="ctr">
               <a:buNone/>
             </a:pPr>
             <a:r>
@@ -3328,6 +3352,13 @@
             <a:prstDash val="solid"/>
           </a:ln>
         </p:spPr>
+        <p:txBody>
+          <a:bodyPr/>
+          <a:lstStyle/>
+          <a:p>
+            <a:endParaRPr lang="es-CL"/>
+          </a:p>
+        </p:txBody>
       </p:sp>
       <p:sp>
         <p:nvSpPr>
@@ -3352,7 +3383,7 @@
           </a:bodyPr>
           <a:lstStyle/>
           <a:p>
-            <a:pPr algn="ctr" indent="0" marL="0">
+            <a:pPr marL="0" indent="0" algn="ctr">
               <a:buNone/>
             </a:pPr>
             <a:r>
@@ -3393,6 +3424,13 @@
             <a:prstDash val="solid"/>
           </a:ln>
         </p:spPr>
+        <p:txBody>
+          <a:bodyPr/>
+          <a:lstStyle/>
+          <a:p>
+            <a:endParaRPr lang="es-CL"/>
+          </a:p>
+        </p:txBody>
       </p:sp>
       <p:sp>
         <p:nvSpPr>
@@ -3417,7 +3455,7 @@
           </a:bodyPr>
           <a:lstStyle/>
           <a:p>
-            <a:pPr algn="ctr" indent="0" marL="0">
+            <a:pPr marL="0" indent="0" algn="ctr">
               <a:buNone/>
             </a:pPr>
             <a:r>
@@ -3448,6 +3486,7 @@
         <a:solidFill>
           <a:srgbClr val="F7FBFC"/>
         </a:solidFill>
+        <a:effectLst/>
       </p:bgPr>
     </p:bg>
     <p:spTree>
@@ -3485,7 +3524,7 @@
           <a:bodyPr wrap="square" lIns="0" tIns="0" rIns="0" bIns="0" rtlCol="0" anchor="ctr"/>
           <a:lstStyle/>
           <a:p>
-            <a:pPr indent="0" marL="0">
+            <a:pPr marL="0" indent="0">
               <a:buNone/>
             </a:pPr>
             <a:r>
@@ -3524,7 +3563,7 @@
           <a:bodyPr wrap="square" lIns="0" tIns="0" rIns="0" bIns="0" rtlCol="0" anchor="ctr"/>
           <a:lstStyle/>
           <a:p>
-            <a:pPr indent="0" marL="0">
+            <a:pPr marL="0" indent="0">
               <a:buNone/>
             </a:pPr>
             <a:r>
@@ -3547,7 +3586,7 @@
         </p:nvSpPr>
         <p:spPr>
           <a:xfrm>
-            <a:off x="1463040" y="2761488"/>
+            <a:off x="2372360" y="3086608"/>
             <a:ext cx="1005840" cy="0"/>
           </a:xfrm>
           <a:prstGeom prst="line">
@@ -3563,6 +3602,13 @@
             <a:tailEnd type="triangle"/>
           </a:ln>
         </p:spPr>
+        <p:txBody>
+          <a:bodyPr/>
+          <a:lstStyle/>
+          <a:p>
+            <a:endParaRPr lang="es-CL"/>
+          </a:p>
+        </p:txBody>
       </p:sp>
       <p:sp>
         <p:nvSpPr>
@@ -3572,7 +3618,7 @@
         </p:nvSpPr>
         <p:spPr>
           <a:xfrm>
-            <a:off x="4023360" y="2761488"/>
+            <a:off x="4876800" y="3086608"/>
             <a:ext cx="1005840" cy="0"/>
           </a:xfrm>
           <a:prstGeom prst="line">
@@ -3588,6 +3634,13 @@
             <a:tailEnd type="triangle"/>
           </a:ln>
         </p:spPr>
+        <p:txBody>
+          <a:bodyPr/>
+          <a:lstStyle/>
+          <a:p>
+            <a:endParaRPr lang="es-CL"/>
+          </a:p>
+        </p:txBody>
       </p:sp>
       <p:sp>
         <p:nvSpPr>
@@ -3597,7 +3650,7 @@
         </p:nvSpPr>
         <p:spPr>
           <a:xfrm>
-            <a:off x="6583680" y="2761488"/>
+            <a:off x="6854444" y="3094736"/>
             <a:ext cx="1005840" cy="0"/>
           </a:xfrm>
           <a:prstGeom prst="line">
@@ -3613,6 +3666,13 @@
             <a:tailEnd type="triangle"/>
           </a:ln>
         </p:spPr>
+        <p:txBody>
+          <a:bodyPr/>
+          <a:lstStyle/>
+          <a:p>
+            <a:endParaRPr lang="es-CL"/>
+          </a:p>
+        </p:txBody>
       </p:sp>
       <p:sp>
         <p:nvSpPr>
@@ -3622,7 +3682,7 @@
         </p:nvSpPr>
         <p:spPr>
           <a:xfrm>
-            <a:off x="9144000" y="2761488"/>
+            <a:off x="9192768" y="3094736"/>
             <a:ext cx="1005840" cy="0"/>
           </a:xfrm>
           <a:prstGeom prst="line">
@@ -3638,6 +3698,13 @@
             <a:tailEnd type="triangle"/>
           </a:ln>
         </p:spPr>
+        <p:txBody>
+          <a:bodyPr/>
+          <a:lstStyle/>
+          <a:p>
+            <a:endParaRPr lang="es-CL"/>
+          </a:p>
+        </p:txBody>
       </p:sp>
       <p:sp>
         <p:nvSpPr>
@@ -3665,13 +3732,20 @@
             <a:prstDash val="solid"/>
           </a:ln>
           <a:effectLst>
-            <a:outerShdw sx="100000" sy="100000" kx="0" ky="0" algn="bl" rotWithShape="0" blurRad="12700" dist="50800" dir="2700000">
+            <a:outerShdw blurRad="12700" dist="50800" dir="2700000" algn="bl" rotWithShape="0">
               <a:srgbClr val="D5DEE7">
                 <a:alpha val="24000"/>
               </a:srgbClr>
             </a:outerShdw>
           </a:effectLst>
         </p:spPr>
+        <p:txBody>
+          <a:bodyPr/>
+          <a:lstStyle/>
+          <a:p>
+            <a:endParaRPr lang="es-CL"/>
+          </a:p>
+        </p:txBody>
       </p:sp>
       <p:sp>
         <p:nvSpPr>
@@ -3696,7 +3770,7 @@
           </a:bodyPr>
           <a:lstStyle/>
           <a:p>
-            <a:pPr algn="ctr" indent="0" marL="0">
+            <a:pPr marL="0" indent="0" algn="ctr">
               <a:buNone/>
             </a:pPr>
             <a:r>
@@ -3710,7 +3784,7 @@
             <a:endParaRPr lang="en-US" sz="1100" dirty="0"/>
           </a:p>
           <a:p>
-            <a:pPr algn="ctr" indent="0" marL="0">
+            <a:pPr marL="0" indent="0" algn="ctr">
               <a:buNone/>
             </a:pPr>
             <a:r>
@@ -3724,7 +3798,7 @@
             <a:endParaRPr lang="en-US" sz="1100" dirty="0"/>
           </a:p>
           <a:p>
-            <a:pPr algn="ctr" indent="0" marL="0">
+            <a:pPr marL="0" indent="0" algn="ctr">
               <a:buNone/>
             </a:pPr>
             <a:r>
@@ -3738,7 +3812,7 @@
             <a:endParaRPr lang="en-US" sz="1100" dirty="0"/>
           </a:p>
           <a:p>
-            <a:pPr algn="ctr" indent="0" marL="0">
+            <a:pPr marL="0" indent="0" algn="ctr">
               <a:buNone/>
             </a:pPr>
             <a:r>
@@ -3779,13 +3853,20 @@
             <a:prstDash val="solid"/>
           </a:ln>
           <a:effectLst>
-            <a:outerShdw sx="100000" sy="100000" kx="0" ky="0" algn="bl" rotWithShape="0" blurRad="12700" dist="50800" dir="2700000">
+            <a:outerShdw blurRad="12700" dist="50800" dir="2700000" algn="bl" rotWithShape="0">
               <a:srgbClr val="D5DEE7">
                 <a:alpha val="24000"/>
               </a:srgbClr>
             </a:outerShdw>
           </a:effectLst>
         </p:spPr>
+        <p:txBody>
+          <a:bodyPr/>
+          <a:lstStyle/>
+          <a:p>
+            <a:endParaRPr lang="es-CL"/>
+          </a:p>
+        </p:txBody>
       </p:sp>
       <p:sp>
         <p:nvSpPr>
@@ -3810,7 +3891,7 @@
           </a:bodyPr>
           <a:lstStyle/>
           <a:p>
-            <a:pPr algn="ctr" indent="0" marL="0">
+            <a:pPr marL="0" indent="0" algn="ctr">
               <a:buNone/>
             </a:pPr>
             <a:r>
@@ -3824,7 +3905,7 @@
             <a:endParaRPr lang="en-US" sz="1100" dirty="0"/>
           </a:p>
           <a:p>
-            <a:pPr algn="ctr" indent="0" marL="0">
+            <a:pPr marL="0" indent="0" algn="ctr">
               <a:buNone/>
             </a:pPr>
             <a:r>
@@ -3838,7 +3919,7 @@
             <a:endParaRPr lang="en-US" sz="1100" dirty="0"/>
           </a:p>
           <a:p>
-            <a:pPr algn="ctr" indent="0" marL="0">
+            <a:pPr marL="0" indent="0" algn="ctr">
               <a:buNone/>
             </a:pPr>
             <a:r>
@@ -3852,7 +3933,7 @@
             <a:endParaRPr lang="en-US" sz="1100" dirty="0"/>
           </a:p>
           <a:p>
-            <a:pPr algn="ctr" indent="0" marL="0">
+            <a:pPr marL="0" indent="0" algn="ctr">
               <a:buNone/>
             </a:pPr>
             <a:r>
@@ -3893,13 +3974,20 @@
             <a:prstDash val="solid"/>
           </a:ln>
           <a:effectLst>
-            <a:outerShdw sx="100000" sy="100000" kx="0" ky="0" algn="bl" rotWithShape="0" blurRad="12700" dist="50800" dir="2700000">
+            <a:outerShdw blurRad="12700" dist="50800" dir="2700000" algn="bl" rotWithShape="0">
               <a:srgbClr val="D5DEE7">
                 <a:alpha val="24000"/>
               </a:srgbClr>
             </a:outerShdw>
           </a:effectLst>
         </p:spPr>
+        <p:txBody>
+          <a:bodyPr/>
+          <a:lstStyle/>
+          <a:p>
+            <a:endParaRPr lang="es-CL"/>
+          </a:p>
+        </p:txBody>
       </p:sp>
       <p:sp>
         <p:nvSpPr>
@@ -3924,7 +4012,7 @@
           </a:bodyPr>
           <a:lstStyle/>
           <a:p>
-            <a:pPr algn="ctr" indent="0" marL="0">
+            <a:pPr marL="0" indent="0" algn="ctr">
               <a:buNone/>
             </a:pPr>
             <a:r>
@@ -3938,7 +4026,7 @@
             <a:endParaRPr lang="en-US" sz="1100" dirty="0"/>
           </a:p>
           <a:p>
-            <a:pPr algn="ctr" indent="0" marL="0">
+            <a:pPr marL="0" indent="0" algn="ctr">
               <a:buNone/>
             </a:pPr>
             <a:r>
@@ -3952,7 +4040,7 @@
             <a:endParaRPr lang="en-US" sz="1100" dirty="0"/>
           </a:p>
           <a:p>
-            <a:pPr algn="ctr" indent="0" marL="0">
+            <a:pPr marL="0" indent="0" algn="ctr">
               <a:buNone/>
             </a:pPr>
             <a:r>
@@ -3966,7 +4054,7 @@
             <a:endParaRPr lang="en-US" sz="1100" dirty="0"/>
           </a:p>
           <a:p>
-            <a:pPr algn="ctr" indent="0" marL="0">
+            <a:pPr marL="0" indent="0" algn="ctr">
               <a:buNone/>
             </a:pPr>
             <a:r>
@@ -3989,7 +4077,7 @@
         </p:nvSpPr>
         <p:spPr>
           <a:xfrm>
-            <a:off x="502920" y="2761488"/>
+            <a:off x="868680" y="2761488"/>
             <a:ext cx="1828800" cy="658368"/>
           </a:xfrm>
           <a:prstGeom prst="roundRect">
@@ -4007,6 +4095,13 @@
             <a:prstDash val="solid"/>
           </a:ln>
         </p:spPr>
+        <p:txBody>
+          <a:bodyPr/>
+          <a:lstStyle/>
+          <a:p>
+            <a:endParaRPr lang="es-CL"/>
+          </a:p>
+        </p:txBody>
       </p:sp>
       <p:sp>
         <p:nvSpPr>
@@ -4016,7 +4111,7 @@
         </p:nvSpPr>
         <p:spPr>
           <a:xfrm>
-            <a:off x="576072" y="2816352"/>
+            <a:off x="941832" y="2816352"/>
             <a:ext cx="1682496" cy="548640"/>
           </a:xfrm>
           <a:prstGeom prst="rect">
@@ -4031,7 +4126,7 @@
           </a:bodyPr>
           <a:lstStyle/>
           <a:p>
-            <a:pPr algn="ctr" indent="0" marL="0">
+            <a:pPr marL="0" indent="0" algn="ctr">
               <a:buNone/>
             </a:pPr>
             <a:r>
@@ -4045,7 +4140,7 @@
             <a:endParaRPr lang="en-US" sz="1050" dirty="0"/>
           </a:p>
           <a:p>
-            <a:pPr algn="ctr" indent="0" marL="0">
+            <a:pPr marL="0" indent="0" algn="ctr">
               <a:buNone/>
             </a:pPr>
             <a:r>
@@ -4068,7 +4163,7 @@
         </p:nvSpPr>
         <p:spPr>
           <a:xfrm>
-            <a:off x="2788920" y="2761488"/>
+            <a:off x="3296920" y="2761488"/>
             <a:ext cx="1828800" cy="658368"/>
           </a:xfrm>
           <a:prstGeom prst="roundRect">
@@ -4086,6 +4181,13 @@
             <a:prstDash val="solid"/>
           </a:ln>
         </p:spPr>
+        <p:txBody>
+          <a:bodyPr/>
+          <a:lstStyle/>
+          <a:p>
+            <a:endParaRPr lang="es-CL"/>
+          </a:p>
+        </p:txBody>
       </p:sp>
       <p:sp>
         <p:nvSpPr>
@@ -4095,7 +4197,7 @@
         </p:nvSpPr>
         <p:spPr>
           <a:xfrm>
-            <a:off x="2862072" y="2816352"/>
+            <a:off x="3370072" y="2816352"/>
             <a:ext cx="1682496" cy="548640"/>
           </a:xfrm>
           <a:prstGeom prst="rect">
@@ -4110,7 +4212,7 @@
           </a:bodyPr>
           <a:lstStyle/>
           <a:p>
-            <a:pPr algn="ctr" indent="0" marL="0">
+            <a:pPr marL="0" indent="0" algn="ctr">
               <a:buNone/>
             </a:pPr>
             <a:r>
@@ -4124,7 +4226,7 @@
             <a:endParaRPr lang="en-US" sz="1050" dirty="0"/>
           </a:p>
           <a:p>
-            <a:pPr algn="ctr" indent="0" marL="0">
+            <a:pPr marL="0" indent="0" algn="ctr">
               <a:buNone/>
             </a:pPr>
             <a:r>
@@ -4147,7 +4249,7 @@
         </p:nvSpPr>
         <p:spPr>
           <a:xfrm>
-            <a:off x="5074920" y="2761488"/>
+            <a:off x="5928360" y="2761488"/>
             <a:ext cx="1828800" cy="658368"/>
           </a:xfrm>
           <a:prstGeom prst="roundRect">
@@ -4165,6 +4267,13 @@
             <a:prstDash val="solid"/>
           </a:ln>
         </p:spPr>
+        <p:txBody>
+          <a:bodyPr/>
+          <a:lstStyle/>
+          <a:p>
+            <a:endParaRPr lang="es-CL"/>
+          </a:p>
+        </p:txBody>
       </p:sp>
       <p:sp>
         <p:nvSpPr>
@@ -4174,7 +4283,7 @@
         </p:nvSpPr>
         <p:spPr>
           <a:xfrm>
-            <a:off x="5148072" y="2816352"/>
+            <a:off x="6001512" y="2816352"/>
             <a:ext cx="1682496" cy="548640"/>
           </a:xfrm>
           <a:prstGeom prst="rect">
@@ -4189,7 +4298,7 @@
           </a:bodyPr>
           <a:lstStyle/>
           <a:p>
-            <a:pPr algn="ctr" indent="0" marL="0">
+            <a:pPr marL="0" indent="0" algn="ctr">
               <a:buNone/>
             </a:pPr>
             <a:r>
@@ -4203,7 +4312,7 @@
             <a:endParaRPr lang="en-US" sz="1020" dirty="0"/>
           </a:p>
           <a:p>
-            <a:pPr algn="ctr" indent="0" marL="0">
+            <a:pPr marL="0" indent="0" algn="ctr">
               <a:buNone/>
             </a:pPr>
             <a:r>
@@ -4226,7 +4335,7 @@
         </p:nvSpPr>
         <p:spPr>
           <a:xfrm>
-            <a:off x="7360920" y="2761488"/>
+            <a:off x="8031480" y="2761488"/>
             <a:ext cx="1828800" cy="658368"/>
           </a:xfrm>
           <a:prstGeom prst="roundRect">
@@ -4244,6 +4353,13 @@
             <a:prstDash val="solid"/>
           </a:ln>
         </p:spPr>
+        <p:txBody>
+          <a:bodyPr/>
+          <a:lstStyle/>
+          <a:p>
+            <a:endParaRPr lang="es-CL"/>
+          </a:p>
+        </p:txBody>
       </p:sp>
       <p:sp>
         <p:nvSpPr>
@@ -4253,7 +4369,7 @@
         </p:nvSpPr>
         <p:spPr>
           <a:xfrm>
-            <a:off x="7434072" y="2816352"/>
+            <a:off x="8104632" y="2816352"/>
             <a:ext cx="1682496" cy="548640"/>
           </a:xfrm>
           <a:prstGeom prst="rect">
@@ -4268,7 +4384,7 @@
           </a:bodyPr>
           <a:lstStyle/>
           <a:p>
-            <a:pPr algn="ctr" indent="0" marL="0">
+            <a:pPr marL="0" indent="0" algn="ctr">
               <a:buNone/>
             </a:pPr>
             <a:r>
@@ -4282,7 +4398,7 @@
             <a:endParaRPr lang="en-US" sz="1020" dirty="0"/>
           </a:p>
           <a:p>
-            <a:pPr algn="ctr" indent="0" marL="0">
+            <a:pPr marL="0" indent="0" algn="ctr">
               <a:buNone/>
             </a:pPr>
             <a:r>
@@ -4305,8 +4421,8 @@
         </p:nvSpPr>
         <p:spPr>
           <a:xfrm>
-            <a:off x="9646920" y="2761488"/>
-            <a:ext cx="1828800" cy="658368"/>
+            <a:off x="10337800" y="2761488"/>
+            <a:ext cx="1417320" cy="658368"/>
           </a:xfrm>
           <a:prstGeom prst="roundRect">
             <a:avLst>
@@ -4323,6 +4439,13 @@
             <a:prstDash val="solid"/>
           </a:ln>
         </p:spPr>
+        <p:txBody>
+          <a:bodyPr/>
+          <a:lstStyle/>
+          <a:p>
+            <a:endParaRPr lang="es-CL"/>
+          </a:p>
+        </p:txBody>
       </p:sp>
       <p:sp>
         <p:nvSpPr>
@@ -4332,8 +4455,8 @@
         </p:nvSpPr>
         <p:spPr>
           <a:xfrm>
-            <a:off x="9720072" y="2816352"/>
-            <a:ext cx="1682496" cy="548640"/>
+            <a:off x="10410952" y="2816352"/>
+            <a:ext cx="1344168" cy="548640"/>
           </a:xfrm>
           <a:prstGeom prst="rect">
             <a:avLst/>
@@ -4347,7 +4470,7 @@
           </a:bodyPr>
           <a:lstStyle/>
           <a:p>
-            <a:pPr algn="ctr" indent="0" marL="0">
+            <a:pPr marL="0" indent="0" algn="ctr">
               <a:buNone/>
             </a:pPr>
             <a:r>
@@ -4361,7 +4484,7 @@
             <a:endParaRPr lang="en-US" sz="1020" dirty="0"/>
           </a:p>
           <a:p>
-            <a:pPr algn="ctr" indent="0" marL="0">
+            <a:pPr marL="0" indent="0" algn="ctr">
               <a:buNone/>
             </a:pPr>
             <a:r>
@@ -4402,13 +4525,20 @@
             <a:prstDash val="solid"/>
           </a:ln>
           <a:effectLst>
-            <a:outerShdw sx="100000" sy="100000" kx="0" ky="0" algn="bl" rotWithShape="0" blurRad="12700" dist="50800" dir="2700000">
+            <a:outerShdw blurRad="12700" dist="50800" dir="2700000" algn="bl" rotWithShape="0">
               <a:srgbClr val="D5DEE7">
                 <a:alpha val="24000"/>
               </a:srgbClr>
             </a:outerShdw>
           </a:effectLst>
         </p:spPr>
+        <p:txBody>
+          <a:bodyPr/>
+          <a:lstStyle/>
+          <a:p>
+            <a:endParaRPr lang="es-CL"/>
+          </a:p>
+        </p:txBody>
       </p:sp>
       <p:sp>
         <p:nvSpPr>
@@ -4433,7 +4563,7 @@
           </a:bodyPr>
           <a:lstStyle/>
           <a:p>
-            <a:pPr algn="l" indent="0" marL="0">
+            <a:pPr marL="0" indent="0" algn="l">
               <a:buNone/>
             </a:pPr>
             <a:r>
@@ -4447,7 +4577,7 @@
             <a:endParaRPr lang="en-US" sz="1020" dirty="0"/>
           </a:p>
           <a:p>
-            <a:pPr algn="l" indent="0" marL="0">
+            <a:pPr marL="0" indent="0" algn="l">
               <a:buNone/>
             </a:pPr>
             <a:r>
@@ -4461,7 +4591,7 @@
             <a:endParaRPr lang="en-US" sz="1020" dirty="0"/>
           </a:p>
           <a:p>
-            <a:pPr algn="l" indent="0" marL="0">
+            <a:pPr marL="0" indent="0" algn="l">
               <a:buNone/>
             </a:pPr>
             <a:r>
@@ -4475,7 +4605,7 @@
             <a:endParaRPr lang="en-US" sz="1020" dirty="0"/>
           </a:p>
           <a:p>
-            <a:pPr algn="l" indent="0" marL="0">
+            <a:pPr marL="0" indent="0" algn="l">
               <a:buNone/>
             </a:pPr>
             <a:r>
@@ -4489,7 +4619,7 @@
             <a:endParaRPr lang="en-US" sz="1020" dirty="0"/>
           </a:p>
           <a:p>
-            <a:pPr algn="l" indent="0" marL="0">
+            <a:pPr marL="0" indent="0" algn="l">
               <a:buNone/>
             </a:pPr>
             <a:r>
@@ -4530,13 +4660,20 @@
             <a:prstDash val="solid"/>
           </a:ln>
           <a:effectLst>
-            <a:outerShdw sx="100000" sy="100000" kx="0" ky="0" algn="bl" rotWithShape="0" blurRad="12700" dist="50800" dir="2700000">
+            <a:outerShdw blurRad="12700" dist="50800" dir="2700000" algn="bl" rotWithShape="0">
               <a:srgbClr val="D5DEE7">
                 <a:alpha val="24000"/>
               </a:srgbClr>
             </a:outerShdw>
           </a:effectLst>
         </p:spPr>
+        <p:txBody>
+          <a:bodyPr/>
+          <a:lstStyle/>
+          <a:p>
+            <a:endParaRPr lang="es-CL"/>
+          </a:p>
+        </p:txBody>
       </p:sp>
       <p:sp>
         <p:nvSpPr>
@@ -4561,7 +4698,7 @@
           </a:bodyPr>
           <a:lstStyle/>
           <a:p>
-            <a:pPr algn="l" indent="0" marL="0">
+            <a:pPr marL="0" indent="0" algn="l">
               <a:buNone/>
             </a:pPr>
             <a:r>
@@ -4575,7 +4712,7 @@
             <a:endParaRPr lang="en-US" sz="1020" dirty="0"/>
           </a:p>
           <a:p>
-            <a:pPr algn="l" indent="0" marL="0">
+            <a:pPr marL="0" indent="0" algn="l">
               <a:buNone/>
             </a:pPr>
             <a:r>
@@ -4589,7 +4726,7 @@
             <a:endParaRPr lang="en-US" sz="1020" dirty="0"/>
           </a:p>
           <a:p>
-            <a:pPr algn="l" indent="0" marL="0">
+            <a:pPr marL="0" indent="0" algn="l">
               <a:buNone/>
             </a:pPr>
             <a:r>
@@ -4603,7 +4740,7 @@
             <a:endParaRPr lang="en-US" sz="1020" dirty="0"/>
           </a:p>
           <a:p>
-            <a:pPr algn="l" indent="0" marL="0">
+            <a:pPr marL="0" indent="0" algn="l">
               <a:buNone/>
             </a:pPr>
             <a:r>
@@ -4617,7 +4754,7 @@
             <a:endParaRPr lang="en-US" sz="1020" dirty="0"/>
           </a:p>
           <a:p>
-            <a:pPr algn="l" indent="0" marL="0">
+            <a:pPr marL="0" indent="0" algn="l">
               <a:buNone/>
             </a:pPr>
             <a:r>
@@ -4658,13 +4795,20 @@
             <a:prstDash val="solid"/>
           </a:ln>
           <a:effectLst>
-            <a:outerShdw sx="100000" sy="100000" kx="0" ky="0" algn="bl" rotWithShape="0" blurRad="12700" dist="50800" dir="2700000">
+            <a:outerShdw blurRad="12700" dist="50800" dir="2700000" algn="bl" rotWithShape="0">
               <a:srgbClr val="D5DEE7">
                 <a:alpha val="24000"/>
               </a:srgbClr>
             </a:outerShdw>
           </a:effectLst>
         </p:spPr>
+        <p:txBody>
+          <a:bodyPr/>
+          <a:lstStyle/>
+          <a:p>
+            <a:endParaRPr lang="es-CL"/>
+          </a:p>
+        </p:txBody>
       </p:sp>
       <p:sp>
         <p:nvSpPr>
@@ -4689,7 +4833,7 @@
           </a:bodyPr>
           <a:lstStyle/>
           <a:p>
-            <a:pPr algn="l" indent="0" marL="0">
+            <a:pPr marL="0" indent="0" algn="l">
               <a:buNone/>
             </a:pPr>
             <a:r>
@@ -4703,7 +4847,7 @@
             <a:endParaRPr lang="en-US" sz="1020" dirty="0"/>
           </a:p>
           <a:p>
-            <a:pPr algn="l" indent="0" marL="0">
+            <a:pPr marL="0" indent="0" algn="l">
               <a:buNone/>
             </a:pPr>
             <a:r>
@@ -4717,7 +4861,7 @@
             <a:endParaRPr lang="en-US" sz="1020" dirty="0"/>
           </a:p>
           <a:p>
-            <a:pPr algn="l" indent="0" marL="0">
+            <a:pPr marL="0" indent="0" algn="l">
               <a:buNone/>
             </a:pPr>
             <a:r>
@@ -4731,7 +4875,7 @@
             <a:endParaRPr lang="en-US" sz="1020" dirty="0"/>
           </a:p>
           <a:p>
-            <a:pPr algn="l" indent="0" marL="0">
+            <a:pPr marL="0" indent="0" algn="l">
               <a:buNone/>
             </a:pPr>
             <a:r>
@@ -4745,7 +4889,7 @@
             <a:endParaRPr lang="en-US" sz="1020" dirty="0"/>
           </a:p>
           <a:p>
-            <a:pPr algn="l" indent="0" marL="0">
+            <a:pPr marL="0" indent="0" algn="l">
               <a:buNone/>
             </a:pPr>
             <a:r>
@@ -4786,13 +4930,20 @@
             <a:prstDash val="solid"/>
           </a:ln>
           <a:effectLst>
-            <a:outerShdw sx="100000" sy="100000" kx="0" ky="0" algn="bl" rotWithShape="0" blurRad="12700" dist="50800" dir="2700000">
+            <a:outerShdw blurRad="12700" dist="50800" dir="2700000" algn="bl" rotWithShape="0">
               <a:srgbClr val="D5DEE7">
                 <a:alpha val="24000"/>
               </a:srgbClr>
             </a:outerShdw>
           </a:effectLst>
         </p:spPr>
+        <p:txBody>
+          <a:bodyPr/>
+          <a:lstStyle/>
+          <a:p>
+            <a:endParaRPr lang="es-CL"/>
+          </a:p>
+        </p:txBody>
       </p:sp>
       <p:sp>
         <p:nvSpPr>
@@ -4817,7 +4968,7 @@
           </a:bodyPr>
           <a:lstStyle/>
           <a:p>
-            <a:pPr algn="l" indent="0" marL="0">
+            <a:pPr marL="0" indent="0" algn="l">
               <a:buNone/>
             </a:pPr>
             <a:r>
@@ -4831,7 +4982,7 @@
             <a:endParaRPr lang="en-US" sz="1020" dirty="0"/>
           </a:p>
           <a:p>
-            <a:pPr algn="l" indent="0" marL="0">
+            <a:pPr marL="0" indent="0" algn="l">
               <a:buNone/>
             </a:pPr>
             <a:r>
@@ -4845,7 +4996,7 @@
             <a:endParaRPr lang="en-US" sz="1020" dirty="0"/>
           </a:p>
           <a:p>
-            <a:pPr algn="l" indent="0" marL="0">
+            <a:pPr marL="0" indent="0" algn="l">
               <a:buNone/>
             </a:pPr>
             <a:r>
@@ -4859,7 +5010,7 @@
             <a:endParaRPr lang="en-US" sz="1020" dirty="0"/>
           </a:p>
           <a:p>
-            <a:pPr algn="l" indent="0" marL="0">
+            <a:pPr marL="0" indent="0" algn="l">
               <a:buNone/>
             </a:pPr>
             <a:r>
@@ -4873,7 +5024,7 @@
             <a:endParaRPr lang="en-US" sz="1020" dirty="0"/>
           </a:p>
           <a:p>
-            <a:pPr algn="l" indent="0" marL="0">
+            <a:pPr marL="0" indent="0" algn="l">
               <a:buNone/>
             </a:pPr>
             <a:r>
@@ -4914,6 +5065,13 @@
             <a:prstDash val="solid"/>
           </a:ln>
         </p:spPr>
+        <p:txBody>
+          <a:bodyPr/>
+          <a:lstStyle/>
+          <a:p>
+            <a:endParaRPr lang="es-CL"/>
+          </a:p>
+        </p:txBody>
       </p:sp>
       <p:sp>
         <p:nvSpPr>
@@ -4938,7 +5096,7 @@
           </a:bodyPr>
           <a:lstStyle/>
           <a:p>
-            <a:pPr algn="ctr" indent="0" marL="0">
+            <a:pPr marL="0" indent="0" algn="ctr">
               <a:buNone/>
             </a:pPr>
             <a:r>
@@ -4947,7 +5105,23 @@
                   <a:srgbClr val="FFFFFF"/>
                 </a:solidFill>
               </a:rPr>
-              <a:t>Decisión arquitectónica: no migrar a cPanel. Vercel + Supabase es adecuado para MVP y crecimiento progresivo; se endurece por etapas antes de producción real.</a:t>
+              <a:t>Decisión arquitectónica: no migrar a  Hosting </a:t>
+            </a:r>
+            <a:r>
+              <a:rPr lang="en-US" sz="1020" b="1" dirty="0" err="1">
+                <a:solidFill>
+                  <a:srgbClr val="FFFFFF"/>
+                </a:solidFill>
+              </a:rPr>
+              <a:t>aún</a:t>
+            </a:r>
+            <a:r>
+              <a:rPr lang="en-US" sz="1020" b="1" dirty="0">
+                <a:solidFill>
+                  <a:srgbClr val="FFFFFF"/>
+                </a:solidFill>
+              </a:rPr>
+              <a:t>. Vercel + Supabase es adecuado para MVP y crecimiento progresivo; se endurece por etapas antes de producción real.</a:t>
             </a:r>
             <a:endParaRPr lang="en-US" sz="1020" dirty="0"/>
           </a:p>
@@ -5254,4 +5428,319 @@
     </a:ext>
   </a:extLst>
 </a:theme>
+</file>
+
+<file path=ppt/theme/theme2.xml><?xml version="1.0" encoding="utf-8"?>
+<a:theme xmlns:a="http://schemas.openxmlformats.org/drawingml/2006/main" name="Tema de Office">
+  <a:themeElements>
+    <a:clrScheme name="Office">
+      <a:dk1>
+        <a:sysClr val="windowText" lastClr="000000"/>
+      </a:dk1>
+      <a:lt1>
+        <a:sysClr val="window" lastClr="FFFFFF"/>
+      </a:lt1>
+      <a:dk2>
+        <a:srgbClr val="0E2841"/>
+      </a:dk2>
+      <a:lt2>
+        <a:srgbClr val="E8E8E8"/>
+      </a:lt2>
+      <a:accent1>
+        <a:srgbClr val="156082"/>
+      </a:accent1>
+      <a:accent2>
+        <a:srgbClr val="E97132"/>
+      </a:accent2>
+      <a:accent3>
+        <a:srgbClr val="196B24"/>
+      </a:accent3>
+      <a:accent4>
+        <a:srgbClr val="0F9ED5"/>
+      </a:accent4>
+      <a:accent5>
+        <a:srgbClr val="A02B93"/>
+      </a:accent5>
+      <a:accent6>
+        <a:srgbClr val="4EA72E"/>
+      </a:accent6>
+      <a:hlink>
+        <a:srgbClr val="467886"/>
+      </a:hlink>
+      <a:folHlink>
+        <a:srgbClr val="96607D"/>
+      </a:folHlink>
+    </a:clrScheme>
+    <a:fontScheme name="Office">
+      <a:majorFont>
+        <a:latin typeface="Aptos Display" panose="02110004020202020204"/>
+        <a:ea typeface=""/>
+        <a:cs typeface=""/>
+        <a:font script="Jpan" typeface="游ゴシック Light"/>
+        <a:font script="Hang" typeface="맑은 고딕"/>
+        <a:font script="Hans" typeface="等线 Light"/>
+        <a:font script="Hant" typeface="新細明體"/>
+        <a:font script="Arab" typeface="Times New Roman"/>
+        <a:font script="Hebr" typeface="Times New Roman"/>
+        <a:font script="Thai" typeface="Angsana New"/>
+        <a:font script="Ethi" typeface="Nyala"/>
+        <a:font script="Beng" typeface="Vrinda"/>
+        <a:font script="Gujr" typeface="Shruti"/>
+        <a:font script="Khmr" typeface="MoolBoran"/>
+        <a:font script="Knda" typeface="Tunga"/>
+        <a:font script="Guru" typeface="Raavi"/>
+        <a:font script="Cans" typeface="Euphemia"/>
+        <a:font script="Cher" typeface="Plantagenet Cherokee"/>
+        <a:font script="Yiii" typeface="Microsoft Yi Baiti"/>
+        <a:font script="Tibt" typeface="Microsoft Himalaya"/>
+        <a:font script="Thaa" typeface="MV Boli"/>
+        <a:font script="Deva" typeface="Mangal"/>
+        <a:font script="Telu" typeface="Gautami"/>
+        <a:font script="Taml" typeface="Latha"/>
+        <a:font script="Syrc" typeface="Estrangelo Edessa"/>
+        <a:font script="Orya" typeface="Kalinga"/>
+        <a:font script="Mlym" typeface="Kartika"/>
+        <a:font script="Laoo" typeface="DokChampa"/>
+        <a:font script="Sinh" typeface="Iskoola Pota"/>
+        <a:font script="Mong" typeface="Mongolian Baiti"/>
+        <a:font script="Viet" typeface="Times New Roman"/>
+        <a:font script="Uigh" typeface="Microsoft Uighur"/>
+        <a:font script="Geor" typeface="Sylfaen"/>
+        <a:font script="Armn" typeface="Arial"/>
+        <a:font script="Bugi" typeface="Leelawadee UI"/>
+        <a:font script="Bopo" typeface="Microsoft JhengHei"/>
+        <a:font script="Java" typeface="Javanese Text"/>
+        <a:font script="Lisu" typeface="Segoe UI"/>
+        <a:font script="Mymr" typeface="Myanmar Text"/>
+        <a:font script="Nkoo" typeface="Ebrima"/>
+        <a:font script="Olck" typeface="Nirmala UI"/>
+        <a:font script="Osma" typeface="Ebrima"/>
+        <a:font script="Phag" typeface="Phagspa"/>
+        <a:font script="Syrn" typeface="Estrangelo Edessa"/>
+        <a:font script="Syrj" typeface="Estrangelo Edessa"/>
+        <a:font script="Syre" typeface="Estrangelo Edessa"/>
+        <a:font script="Sora" typeface="Nirmala UI"/>
+        <a:font script="Tale" typeface="Microsoft Tai Le"/>
+        <a:font script="Talu" typeface="Microsoft New Tai Lue"/>
+        <a:font script="Tfng" typeface="Ebrima"/>
+      </a:majorFont>
+      <a:minorFont>
+        <a:latin typeface="Aptos" panose="02110004020202020204"/>
+        <a:ea typeface=""/>
+        <a:cs typeface=""/>
+        <a:font script="Jpan" typeface="游ゴシック"/>
+        <a:font script="Hang" typeface="맑은 고딕"/>
+        <a:font script="Hans" typeface="等线"/>
+        <a:font script="Hant" typeface="新細明體"/>
+        <a:font script="Arab" typeface="Arial"/>
+        <a:font script="Hebr" typeface="Arial"/>
+        <a:font script="Thai" typeface="Cordia New"/>
+        <a:font script="Ethi" typeface="Nyala"/>
+        <a:font script="Beng" typeface="Vrinda"/>
+        <a:font script="Gujr" typeface="Shruti"/>
+        <a:font script="Khmr" typeface="DaunPenh"/>
+        <a:font script="Knda" typeface="Tunga"/>
+        <a:font script="Guru" typeface="Raavi"/>
+        <a:font script="Cans" typeface="Euphemia"/>
+        <a:font script="Cher" typeface="Plantagenet Cherokee"/>
+        <a:font script="Yiii" typeface="Microsoft Yi Baiti"/>
+        <a:font script="Tibt" typeface="Microsoft Himalaya"/>
+        <a:font script="Thaa" typeface="MV Boli"/>
+        <a:font script="Deva" typeface="Mangal"/>
+        <a:font script="Telu" typeface="Gautami"/>
+        <a:font script="Taml" typeface="Latha"/>
+        <a:font script="Syrc" typeface="Estrangelo Edessa"/>
+        <a:font script="Orya" typeface="Kalinga"/>
+        <a:font script="Mlym" typeface="Kartika"/>
+        <a:font script="Laoo" typeface="DokChampa"/>
+        <a:font script="Sinh" typeface="Iskoola Pota"/>
+        <a:font script="Mong" typeface="Mongolian Baiti"/>
+        <a:font script="Viet" typeface="Arial"/>
+        <a:font script="Uigh" typeface="Microsoft Uighur"/>
+        <a:font script="Geor" typeface="Sylfaen"/>
+        <a:font script="Armn" typeface="Arial"/>
+        <a:font script="Bugi" typeface="Leelawadee UI"/>
+        <a:font script="Bopo" typeface="Microsoft JhengHei"/>
+        <a:font script="Java" typeface="Javanese Text"/>
+        <a:font script="Lisu" typeface="Segoe UI"/>
+        <a:font script="Mymr" typeface="Myanmar Text"/>
+        <a:font script="Nkoo" typeface="Ebrima"/>
+        <a:font script="Olck" typeface="Nirmala UI"/>
+        <a:font script="Osma" typeface="Ebrima"/>
+        <a:font script="Phag" typeface="Phagspa"/>
+        <a:font script="Syrn" typeface="Estrangelo Edessa"/>
+        <a:font script="Syrj" typeface="Estrangelo Edessa"/>
+        <a:font script="Syre" typeface="Estrangelo Edessa"/>
+        <a:font script="Sora" typeface="Nirmala UI"/>
+        <a:font script="Tale" typeface="Microsoft Tai Le"/>
+        <a:font script="Talu" typeface="Microsoft New Tai Lue"/>
+        <a:font script="Tfng" typeface="Ebrima"/>
+      </a:minorFont>
+    </a:fontScheme>
+    <a:fmtScheme name="Office">
+      <a:fillStyleLst>
+        <a:solidFill>
+          <a:schemeClr val="phClr"/>
+        </a:solidFill>
+        <a:gradFill rotWithShape="1">
+          <a:gsLst>
+            <a:gs pos="0">
+              <a:schemeClr val="phClr">
+                <a:lumMod val="110000"/>
+                <a:satMod val="105000"/>
+                <a:tint val="67000"/>
+              </a:schemeClr>
+            </a:gs>
+            <a:gs pos="50000">
+              <a:schemeClr val="phClr">
+                <a:lumMod val="105000"/>
+                <a:satMod val="103000"/>
+                <a:tint val="73000"/>
+              </a:schemeClr>
+            </a:gs>
+            <a:gs pos="100000">
+              <a:schemeClr val="phClr">
+                <a:lumMod val="105000"/>
+                <a:satMod val="109000"/>
+                <a:tint val="81000"/>
+              </a:schemeClr>
+            </a:gs>
+          </a:gsLst>
+          <a:lin ang="5400000" scaled="0"/>
+        </a:gradFill>
+        <a:gradFill rotWithShape="1">
+          <a:gsLst>
+            <a:gs pos="0">
+              <a:schemeClr val="phClr">
+                <a:satMod val="103000"/>
+                <a:lumMod val="102000"/>
+                <a:tint val="94000"/>
+              </a:schemeClr>
+            </a:gs>
+            <a:gs pos="50000">
+              <a:schemeClr val="phClr">
+                <a:satMod val="110000"/>
+                <a:lumMod val="100000"/>
+                <a:shade val="100000"/>
+              </a:schemeClr>
+            </a:gs>
+            <a:gs pos="100000">
+              <a:schemeClr val="phClr">
+                <a:lumMod val="99000"/>
+                <a:satMod val="120000"/>
+                <a:shade val="78000"/>
+              </a:schemeClr>
+            </a:gs>
+          </a:gsLst>
+          <a:lin ang="5400000" scaled="0"/>
+        </a:gradFill>
+      </a:fillStyleLst>
+      <a:lnStyleLst>
+        <a:ln w="12700" cap="flat" cmpd="sng" algn="ctr">
+          <a:solidFill>
+            <a:schemeClr val="phClr"/>
+          </a:solidFill>
+          <a:prstDash val="solid"/>
+          <a:miter lim="800000"/>
+        </a:ln>
+        <a:ln w="19050" cap="flat" cmpd="sng" algn="ctr">
+          <a:solidFill>
+            <a:schemeClr val="phClr"/>
+          </a:solidFill>
+          <a:prstDash val="solid"/>
+          <a:miter lim="800000"/>
+        </a:ln>
+        <a:ln w="25400" cap="flat" cmpd="sng" algn="ctr">
+          <a:solidFill>
+            <a:schemeClr val="phClr"/>
+          </a:solidFill>
+          <a:prstDash val="solid"/>
+          <a:miter lim="800000"/>
+        </a:ln>
+      </a:lnStyleLst>
+      <a:effectStyleLst>
+        <a:effectStyle>
+          <a:effectLst/>
+        </a:effectStyle>
+        <a:effectStyle>
+          <a:effectLst/>
+        </a:effectStyle>
+        <a:effectStyle>
+          <a:effectLst>
+            <a:outerShdw blurRad="57150" dist="19050" dir="5400000" algn="ctr" rotWithShape="0">
+              <a:srgbClr val="000000">
+                <a:alpha val="63000"/>
+              </a:srgbClr>
+            </a:outerShdw>
+          </a:effectLst>
+        </a:effectStyle>
+      </a:effectStyleLst>
+      <a:bgFillStyleLst>
+        <a:solidFill>
+          <a:schemeClr val="phClr"/>
+        </a:solidFill>
+        <a:solidFill>
+          <a:schemeClr val="phClr">
+            <a:tint val="95000"/>
+            <a:satMod val="170000"/>
+          </a:schemeClr>
+        </a:solidFill>
+        <a:gradFill rotWithShape="1">
+          <a:gsLst>
+            <a:gs pos="0">
+              <a:schemeClr val="phClr">
+                <a:tint val="93000"/>
+                <a:satMod val="150000"/>
+                <a:shade val="98000"/>
+                <a:lumMod val="102000"/>
+              </a:schemeClr>
+            </a:gs>
+            <a:gs pos="50000">
+              <a:schemeClr val="phClr">
+                <a:tint val="98000"/>
+                <a:satMod val="130000"/>
+                <a:shade val="90000"/>
+                <a:lumMod val="103000"/>
+              </a:schemeClr>
+            </a:gs>
+            <a:gs pos="100000">
+              <a:schemeClr val="phClr">
+                <a:shade val="63000"/>
+                <a:satMod val="120000"/>
+              </a:schemeClr>
+            </a:gs>
+          </a:gsLst>
+          <a:lin ang="5400000" scaled="0"/>
+        </a:gradFill>
+      </a:bgFillStyleLst>
+    </a:fmtScheme>
+  </a:themeElements>
+  <a:objectDefaults>
+    <a:lnDef>
+      <a:spPr/>
+      <a:bodyPr/>
+      <a:lstStyle/>
+      <a:style>
+        <a:lnRef idx="2">
+          <a:schemeClr val="accent1"/>
+        </a:lnRef>
+        <a:fillRef idx="0">
+          <a:schemeClr val="accent1"/>
+        </a:fillRef>
+        <a:effectRef idx="1">
+          <a:schemeClr val="accent1"/>
+        </a:effectRef>
+        <a:fontRef idx="minor">
+          <a:schemeClr val="tx1"/>
+        </a:fontRef>
+      </a:style>
+    </a:lnDef>
+  </a:objectDefaults>
+  <a:extraClrSchemeLst/>
+  <a:extLst>
+    <a:ext uri="{05A4C25C-085E-4340-85A3-A5531E510DB2}">
+      <thm15:themeFamily xmlns:thm15="http://schemas.microsoft.com/office/thememl/2012/main" name="Office Theme" id="{2E142A2C-CD16-42D6-873A-C26D2A0506FA}" vid="{1BDDFF52-6CD6-40A5-AB3C-68EB2F1E4D0A}"/>
+    </a:ext>
+  </a:extLst>
+</a:theme>
 </file>
</xml_diff>

<commit_message>
Actualizar disponibilidad, agenda y modalidades
</commit_message>
<xml_diff>
--- a/Diagramas/Arquitectura_Mentalia_FluyePro.pptx
+++ b/Diagramas/Arquitectura_Mentalia_FluyePro.pptx
@@ -5,11 +5,16 @@
     <p:sldMasterId id="2147483648" r:id="rId1"/>
   </p:sldMasterIdLst>
   <p:notesMasterIdLst>
-    <p:notesMasterId r:id="rId4"/>
+    <p:notesMasterId r:id="rId9"/>
   </p:notesMasterIdLst>
   <p:sldIdLst>
     <p:sldId id="256" r:id="rId2"/>
     <p:sldId id="257" r:id="rId3"/>
+    <p:sldId id="258" r:id="rId4"/>
+    <p:sldId id="259" r:id="rId5"/>
+    <p:sldId id="260" r:id="rId6"/>
+    <p:sldId id="262" r:id="rId7"/>
+    <p:sldId id="261" r:id="rId8"/>
   </p:sldIdLst>
   <p:sldSz cx="12192000" cy="6858000"/>
   <p:notesSz cx="6858000" cy="12192000"/>
@@ -3235,7 +3240,7 @@
         </p:spPr>
         <p:txBody>
           <a:bodyPr wrap="square" lIns="254" tIns="254" rIns="254" bIns="254" rtlCol="0" anchor="ctr">
-            <a:normAutofit/>
+            <a:normAutofit lnSpcReduction="10000"/>
           </a:bodyPr>
           <a:lstStyle/>
           <a:p>
@@ -3307,7 +3312,7 @@
         </p:spPr>
         <p:txBody>
           <a:bodyPr wrap="square" lIns="254" tIns="254" rIns="254" bIns="254" rtlCol="0" anchor="ctr">
-            <a:normAutofit/>
+            <a:normAutofit lnSpcReduction="10000"/>
           </a:bodyPr>
           <a:lstStyle/>
           <a:p>
@@ -5128,6 +5133,1175 @@
         </p:txBody>
       </p:sp>
     </p:spTree>
+  </p:cSld>
+  <p:clrMapOvr>
+    <a:masterClrMapping/>
+  </p:clrMapOvr>
+</p:sld>
+</file>
+
+<file path=ppt/slides/slide3.xml><?xml version="1.0" encoding="utf-8"?>
+<p:sld xmlns:a="http://schemas.openxmlformats.org/drawingml/2006/main" xmlns:r="http://schemas.openxmlformats.org/officeDocument/2006/relationships" xmlns:p="http://schemas.openxmlformats.org/presentationml/2006/main">
+  <p:cSld>
+    <p:spTree>
+      <p:nvGrpSpPr>
+        <p:cNvPr id="1" name=""/>
+        <p:cNvGrpSpPr/>
+        <p:nvPr/>
+      </p:nvGrpSpPr>
+      <p:grpSpPr>
+        <a:xfrm>
+          <a:off x="0" y="0"/>
+          <a:ext cx="0" cy="0"/>
+          <a:chOff x="0" y="0"/>
+          <a:chExt cx="0" cy="0"/>
+        </a:xfrm>
+      </p:grpSpPr>
+      <p:pic>
+        <p:nvPicPr>
+          <p:cNvPr id="5" name="Imagen 4">
+            <a:extLst>
+              <a:ext uri="{FF2B5EF4-FFF2-40B4-BE49-F238E27FC236}">
+                <a16:creationId xmlns:a16="http://schemas.microsoft.com/office/drawing/2014/main" id="{CB10BF00-94EF-7AEC-6B24-ECDC9FFC267A}"/>
+              </a:ext>
+            </a:extLst>
+          </p:cNvPr>
+          <p:cNvPicPr>
+            <a:picLocks noChangeAspect="1"/>
+          </p:cNvPicPr>
+          <p:nvPr/>
+        </p:nvPicPr>
+        <p:blipFill>
+          <a:blip r:embed="rId2"/>
+          <a:stretch>
+            <a:fillRect/>
+          </a:stretch>
+        </p:blipFill>
+        <p:spPr>
+          <a:xfrm>
+            <a:off x="2620331" y="620829"/>
+            <a:ext cx="6329313" cy="5616341"/>
+          </a:xfrm>
+          <a:prstGeom prst="rect">
+            <a:avLst/>
+          </a:prstGeom>
+        </p:spPr>
+      </p:pic>
+      <p:sp>
+        <p:nvSpPr>
+          <p:cNvPr id="6" name="CuadroTexto 5">
+            <a:extLst>
+              <a:ext uri="{FF2B5EF4-FFF2-40B4-BE49-F238E27FC236}">
+                <a16:creationId xmlns:a16="http://schemas.microsoft.com/office/drawing/2014/main" id="{09694955-D1F5-54A4-C484-F6717AEA1226}"/>
+              </a:ext>
+            </a:extLst>
+          </p:cNvPr>
+          <p:cNvSpPr txBox="1"/>
+          <p:nvPr/>
+        </p:nvSpPr>
+        <p:spPr>
+          <a:xfrm>
+            <a:off x="1183907" y="731520"/>
+            <a:ext cx="2347822" cy="369332"/>
+          </a:xfrm>
+          <a:prstGeom prst="rect">
+            <a:avLst/>
+          </a:prstGeom>
+          <a:noFill/>
+        </p:spPr>
+        <p:txBody>
+          <a:bodyPr wrap="none" rtlCol="0">
+            <a:spAutoFit/>
+          </a:bodyPr>
+          <a:lstStyle/>
+          <a:p>
+            <a:r>
+              <a:rPr lang="es-CL" dirty="0"/>
+              <a:t>Mapa Actual </a:t>
+            </a:r>
+            <a:r>
+              <a:rPr lang="es-CL" dirty="0" err="1"/>
+              <a:t>Mentalia</a:t>
+            </a:r>
+            <a:endParaRPr lang="es-CL" dirty="0"/>
+          </a:p>
+        </p:txBody>
+      </p:sp>
+    </p:spTree>
+    <p:extLst>
+      <p:ext uri="{BB962C8B-B14F-4D97-AF65-F5344CB8AC3E}">
+        <p14:creationId xmlns:p14="http://schemas.microsoft.com/office/powerpoint/2010/main" val="2621722955"/>
+      </p:ext>
+    </p:extLst>
+  </p:cSld>
+  <p:clrMapOvr>
+    <a:masterClrMapping/>
+  </p:clrMapOvr>
+</p:sld>
+</file>
+
+<file path=ppt/slides/slide4.xml><?xml version="1.0" encoding="utf-8"?>
+<p:sld xmlns:a="http://schemas.openxmlformats.org/drawingml/2006/main" xmlns:r="http://schemas.openxmlformats.org/officeDocument/2006/relationships" xmlns:p="http://schemas.openxmlformats.org/presentationml/2006/main">
+  <p:cSld>
+    <p:spTree>
+      <p:nvGrpSpPr>
+        <p:cNvPr id="1" name=""/>
+        <p:cNvGrpSpPr/>
+        <p:nvPr/>
+      </p:nvGrpSpPr>
+      <p:grpSpPr>
+        <a:xfrm>
+          <a:off x="0" y="0"/>
+          <a:ext cx="0" cy="0"/>
+          <a:chOff x="0" y="0"/>
+          <a:chExt cx="0" cy="0"/>
+        </a:xfrm>
+      </p:grpSpPr>
+      <p:pic>
+        <p:nvPicPr>
+          <p:cNvPr id="3" name="Imagen 2">
+            <a:extLst>
+              <a:ext uri="{FF2B5EF4-FFF2-40B4-BE49-F238E27FC236}">
+                <a16:creationId xmlns:a16="http://schemas.microsoft.com/office/drawing/2014/main" id="{7B8F0E5E-2B99-048D-BDE3-79C7D4F88BE3}"/>
+              </a:ext>
+            </a:extLst>
+          </p:cNvPr>
+          <p:cNvPicPr>
+            <a:picLocks noChangeAspect="1"/>
+          </p:cNvPicPr>
+          <p:nvPr/>
+        </p:nvPicPr>
+        <p:blipFill>
+          <a:blip r:embed="rId2"/>
+          <a:stretch>
+            <a:fillRect/>
+          </a:stretch>
+        </p:blipFill>
+        <p:spPr>
+          <a:xfrm>
+            <a:off x="2194559" y="585887"/>
+            <a:ext cx="7968515" cy="5194084"/>
+          </a:xfrm>
+          <a:prstGeom prst="rect">
+            <a:avLst/>
+          </a:prstGeom>
+        </p:spPr>
+      </p:pic>
+      <p:sp>
+        <p:nvSpPr>
+          <p:cNvPr id="4" name="CuadroTexto 3">
+            <a:extLst>
+              <a:ext uri="{FF2B5EF4-FFF2-40B4-BE49-F238E27FC236}">
+                <a16:creationId xmlns:a16="http://schemas.microsoft.com/office/drawing/2014/main" id="{03AFDCDA-C6E0-1C81-A948-7D05D596963B}"/>
+              </a:ext>
+            </a:extLst>
+          </p:cNvPr>
+          <p:cNvSpPr txBox="1"/>
+          <p:nvPr/>
+        </p:nvSpPr>
+        <p:spPr>
+          <a:xfrm>
+            <a:off x="798897" y="664143"/>
+            <a:ext cx="2377830" cy="369332"/>
+          </a:xfrm>
+          <a:prstGeom prst="rect">
+            <a:avLst/>
+          </a:prstGeom>
+          <a:noFill/>
+        </p:spPr>
+        <p:txBody>
+          <a:bodyPr wrap="none" rtlCol="0">
+            <a:spAutoFit/>
+          </a:bodyPr>
+          <a:lstStyle/>
+          <a:p>
+            <a:r>
+              <a:rPr lang="es-CL" dirty="0"/>
+              <a:t>Plan Mejoras </a:t>
+            </a:r>
+            <a:r>
+              <a:rPr lang="es-CL" dirty="0" err="1"/>
+              <a:t>Mentalia</a:t>
+            </a:r>
+            <a:endParaRPr lang="es-CL" dirty="0"/>
+          </a:p>
+        </p:txBody>
+      </p:sp>
+    </p:spTree>
+    <p:extLst>
+      <p:ext uri="{BB962C8B-B14F-4D97-AF65-F5344CB8AC3E}">
+        <p14:creationId xmlns:p14="http://schemas.microsoft.com/office/powerpoint/2010/main" val="352326368"/>
+      </p:ext>
+    </p:extLst>
+  </p:cSld>
+  <p:clrMapOvr>
+    <a:masterClrMapping/>
+  </p:clrMapOvr>
+</p:sld>
+</file>
+
+<file path=ppt/slides/slide5.xml><?xml version="1.0" encoding="utf-8"?>
+<p:sld xmlns:a="http://schemas.openxmlformats.org/drawingml/2006/main" xmlns:r="http://schemas.openxmlformats.org/officeDocument/2006/relationships" xmlns:p="http://schemas.openxmlformats.org/presentationml/2006/main">
+  <p:cSld>
+    <p:spTree>
+      <p:nvGrpSpPr>
+        <p:cNvPr id="1" name=""/>
+        <p:cNvGrpSpPr/>
+        <p:nvPr/>
+      </p:nvGrpSpPr>
+      <p:grpSpPr>
+        <a:xfrm>
+          <a:off x="0" y="0"/>
+          <a:ext cx="0" cy="0"/>
+          <a:chOff x="0" y="0"/>
+          <a:chExt cx="0" cy="0"/>
+        </a:xfrm>
+      </p:grpSpPr>
+      <p:graphicFrame>
+        <p:nvGraphicFramePr>
+          <p:cNvPr id="2" name="Tabla 1">
+            <a:extLst>
+              <a:ext uri="{FF2B5EF4-FFF2-40B4-BE49-F238E27FC236}">
+                <a16:creationId xmlns:a16="http://schemas.microsoft.com/office/drawing/2014/main" id="{57EDA5C3-6BEE-A2D3-74A1-83B320A5D4C8}"/>
+              </a:ext>
+            </a:extLst>
+          </p:cNvPr>
+          <p:cNvGraphicFramePr>
+            <a:graphicFrameLocks noGrp="1"/>
+          </p:cNvGraphicFramePr>
+          <p:nvPr>
+            <p:extLst>
+              <p:ext uri="{D42A27DB-BD31-4B8C-83A1-F6EECF244321}">
+                <p14:modId xmlns:p14="http://schemas.microsoft.com/office/powerpoint/2010/main" val="1765439884"/>
+              </p:ext>
+            </p:extLst>
+          </p:nvPr>
+        </p:nvGraphicFramePr>
+        <p:xfrm>
+          <a:off x="2032000" y="719666"/>
+          <a:ext cx="8128000" cy="4302760"/>
+        </p:xfrm>
+        <a:graphic>
+          <a:graphicData uri="http://schemas.openxmlformats.org/drawingml/2006/table">
+            <a:tbl>
+              <a:tblPr firstRow="1" bandRow="1">
+                <a:tableStyleId>{5C22544A-7EE6-4342-B048-85BDC9FD1C3A}</a:tableStyleId>
+              </a:tblPr>
+              <a:tblGrid>
+                <a:gridCol w="4064000">
+                  <a:extLst>
+                    <a:ext uri="{9D8B030D-6E8A-4147-A177-3AD203B41FA5}">
+                      <a16:colId xmlns:a16="http://schemas.microsoft.com/office/drawing/2014/main" val="3001164159"/>
+                    </a:ext>
+                  </a:extLst>
+                </a:gridCol>
+                <a:gridCol w="4064000">
+                  <a:extLst>
+                    <a:ext uri="{9D8B030D-6E8A-4147-A177-3AD203B41FA5}">
+                      <a16:colId xmlns:a16="http://schemas.microsoft.com/office/drawing/2014/main" val="158685018"/>
+                    </a:ext>
+                  </a:extLst>
+                </a:gridCol>
+              </a:tblGrid>
+              <a:tr h="370840">
+                <a:tc>
+                  <a:txBody>
+                    <a:bodyPr/>
+                    <a:lstStyle/>
+                    <a:p>
+                      <a:r>
+                        <a:rPr lang="es-CL" dirty="0"/>
+                        <a:t>Arquitectura actual</a:t>
+                      </a:r>
+                    </a:p>
+                  </a:txBody>
+                  <a:tcPr/>
+                </a:tc>
+                <a:tc>
+                  <a:txBody>
+                    <a:bodyPr/>
+                    <a:lstStyle/>
+                    <a:p>
+                      <a:r>
+                        <a:rPr lang="es-CL" dirty="0"/>
+                        <a:t>Arquitectura objetivo</a:t>
+                      </a:r>
+                    </a:p>
+                  </a:txBody>
+                  <a:tcPr/>
+                </a:tc>
+                <a:extLst>
+                  <a:ext uri="{0D108BD9-81ED-4DB2-BD59-A6C34878D82A}">
+                    <a16:rowId xmlns:a16="http://schemas.microsoft.com/office/drawing/2014/main" val="3583207225"/>
+                  </a:ext>
+                </a:extLst>
+              </a:tr>
+              <a:tr h="370840">
+                <a:tc>
+                  <a:txBody>
+                    <a:bodyPr/>
+                    <a:lstStyle/>
+                    <a:p>
+                      <a:pPr rtl="0"/>
+                      <a:r>
+                        <a:rPr lang="es-CL" sz="1800" kern="1200" dirty="0">
+                          <a:solidFill>
+                            <a:schemeClr val="dk1"/>
+                          </a:solidFill>
+                          <a:latin typeface="+mn-lt"/>
+                          <a:ea typeface="+mn-ea"/>
+                          <a:cs typeface="+mn-cs"/>
+                        </a:rPr>
+                        <a:t>Usuario</a:t>
+                      </a:r>
+                    </a:p>
+                    <a:p>
+                      <a:pPr rtl="0"/>
+                      <a:r>
+                        <a:rPr lang="es-CL" sz="1800" kern="1200" dirty="0">
+                          <a:solidFill>
+                            <a:schemeClr val="dk1"/>
+                          </a:solidFill>
+                          <a:latin typeface="+mn-lt"/>
+                          <a:ea typeface="+mn-ea"/>
+                          <a:cs typeface="+mn-cs"/>
+                        </a:rPr>
+                        <a:t>  │</a:t>
+                      </a:r>
+                    </a:p>
+                    <a:p>
+                      <a:pPr rtl="0"/>
+                      <a:r>
+                        <a:rPr lang="es-CL" sz="1800" kern="1200" dirty="0">
+                          <a:solidFill>
+                            <a:schemeClr val="dk1"/>
+                          </a:solidFill>
+                          <a:latin typeface="+mn-lt"/>
+                          <a:ea typeface="+mn-ea"/>
+                          <a:cs typeface="+mn-cs"/>
+                        </a:rPr>
+                        <a:t>  ▼</a:t>
+                      </a:r>
+                    </a:p>
+                    <a:p>
+                      <a:pPr rtl="0"/>
+                      <a:r>
+                        <a:rPr lang="es-CL" sz="1800" kern="1200" dirty="0" err="1">
+                          <a:solidFill>
+                            <a:schemeClr val="dk1"/>
+                          </a:solidFill>
+                          <a:latin typeface="+mn-lt"/>
+                          <a:ea typeface="+mn-ea"/>
+                          <a:cs typeface="+mn-cs"/>
+                        </a:rPr>
+                        <a:t>React</a:t>
+                      </a:r>
+                      <a:r>
+                        <a:rPr lang="es-CL" sz="1800" kern="1200" dirty="0">
+                          <a:solidFill>
+                            <a:schemeClr val="dk1"/>
+                          </a:solidFill>
+                          <a:latin typeface="+mn-lt"/>
+                          <a:ea typeface="+mn-ea"/>
+                          <a:cs typeface="+mn-cs"/>
+                        </a:rPr>
+                        <a:t> + Vite</a:t>
+                      </a:r>
+                    </a:p>
+                    <a:p>
+                      <a:pPr rtl="0"/>
+                      <a:r>
+                        <a:rPr lang="es-CL" sz="1800" kern="1200" dirty="0">
+                          <a:solidFill>
+                            <a:schemeClr val="dk1"/>
+                          </a:solidFill>
+                          <a:latin typeface="+mn-lt"/>
+                          <a:ea typeface="+mn-ea"/>
+                          <a:cs typeface="+mn-cs"/>
+                        </a:rPr>
+                        <a:t>(</a:t>
+                      </a:r>
+                      <a:r>
+                        <a:rPr lang="es-CL" sz="1800" kern="1200" dirty="0" err="1">
+                          <a:solidFill>
+                            <a:schemeClr val="dk1"/>
+                          </a:solidFill>
+                          <a:latin typeface="+mn-lt"/>
+                          <a:ea typeface="+mn-ea"/>
+                          <a:cs typeface="+mn-cs"/>
+                        </a:rPr>
+                        <a:t>Vercel</a:t>
+                      </a:r>
+                      <a:r>
+                        <a:rPr lang="es-CL" sz="1800" kern="1200" dirty="0">
+                          <a:solidFill>
+                            <a:schemeClr val="dk1"/>
+                          </a:solidFill>
+                          <a:latin typeface="+mn-lt"/>
+                          <a:ea typeface="+mn-ea"/>
+                          <a:cs typeface="+mn-cs"/>
+                        </a:rPr>
+                        <a:t>)</a:t>
+                      </a:r>
+                    </a:p>
+                    <a:p>
+                      <a:pPr rtl="0"/>
+                      <a:r>
+                        <a:rPr lang="es-CL" sz="1800" kern="1200" dirty="0">
+                          <a:solidFill>
+                            <a:schemeClr val="dk1"/>
+                          </a:solidFill>
+                          <a:latin typeface="+mn-lt"/>
+                          <a:ea typeface="+mn-ea"/>
+                          <a:cs typeface="+mn-cs"/>
+                        </a:rPr>
+                        <a:t>  │</a:t>
+                      </a:r>
+                    </a:p>
+                    <a:p>
+                      <a:pPr rtl="0"/>
+                      <a:r>
+                        <a:rPr lang="es-CL" sz="1800" kern="1200" dirty="0">
+                          <a:solidFill>
+                            <a:schemeClr val="dk1"/>
+                          </a:solidFill>
+                          <a:latin typeface="+mn-lt"/>
+                          <a:ea typeface="+mn-ea"/>
+                          <a:cs typeface="+mn-cs"/>
+                        </a:rPr>
+                        <a:t>  ├── </a:t>
+                      </a:r>
+                      <a:r>
+                        <a:rPr lang="es-CL" sz="1800" kern="1200" dirty="0" err="1">
+                          <a:solidFill>
+                            <a:schemeClr val="dk1"/>
+                          </a:solidFill>
+                          <a:latin typeface="+mn-lt"/>
+                          <a:ea typeface="+mn-ea"/>
+                          <a:cs typeface="+mn-cs"/>
+                        </a:rPr>
+                        <a:t>Supabase</a:t>
+                      </a:r>
+                      <a:r>
+                        <a:rPr lang="es-CL" sz="1800" kern="1200" dirty="0">
+                          <a:solidFill>
+                            <a:schemeClr val="dk1"/>
+                          </a:solidFill>
+                          <a:latin typeface="+mn-lt"/>
+                          <a:ea typeface="+mn-ea"/>
+                          <a:cs typeface="+mn-cs"/>
+                        </a:rPr>
+                        <a:t> Auth</a:t>
+                      </a:r>
+                    </a:p>
+                    <a:p>
+                      <a:pPr rtl="0"/>
+                      <a:r>
+                        <a:rPr lang="es-CL" sz="1800" kern="1200" dirty="0">
+                          <a:solidFill>
+                            <a:schemeClr val="dk1"/>
+                          </a:solidFill>
+                          <a:latin typeface="+mn-lt"/>
+                          <a:ea typeface="+mn-ea"/>
+                          <a:cs typeface="+mn-cs"/>
+                        </a:rPr>
+                        <a:t>  ├── </a:t>
+                      </a:r>
+                      <a:r>
+                        <a:rPr lang="es-CL" sz="1800" kern="1200" dirty="0" err="1">
+                          <a:solidFill>
+                            <a:schemeClr val="dk1"/>
+                          </a:solidFill>
+                          <a:latin typeface="+mn-lt"/>
+                          <a:ea typeface="+mn-ea"/>
+                          <a:cs typeface="+mn-cs"/>
+                        </a:rPr>
+                        <a:t>Supabase</a:t>
+                      </a:r>
+                      <a:r>
+                        <a:rPr lang="es-CL" sz="1800" kern="1200" dirty="0">
+                          <a:solidFill>
+                            <a:schemeClr val="dk1"/>
+                          </a:solidFill>
+                          <a:latin typeface="+mn-lt"/>
+                          <a:ea typeface="+mn-ea"/>
+                          <a:cs typeface="+mn-cs"/>
+                        </a:rPr>
+                        <a:t> Data API + RLS</a:t>
+                      </a:r>
+                    </a:p>
+                    <a:p>
+                      <a:pPr rtl="0"/>
+                      <a:r>
+                        <a:rPr lang="es-CL" sz="1800" kern="1200" dirty="0">
+                          <a:solidFill>
+                            <a:schemeClr val="dk1"/>
+                          </a:solidFill>
+                          <a:latin typeface="+mn-lt"/>
+                          <a:ea typeface="+mn-ea"/>
+                          <a:cs typeface="+mn-cs"/>
+                        </a:rPr>
+                        <a:t>  ├── </a:t>
+                      </a:r>
+                      <a:r>
+                        <a:rPr lang="es-CL" sz="1800" kern="1200" dirty="0" err="1">
+                          <a:solidFill>
+                            <a:schemeClr val="dk1"/>
+                          </a:solidFill>
+                          <a:latin typeface="+mn-lt"/>
+                          <a:ea typeface="+mn-ea"/>
+                          <a:cs typeface="+mn-cs"/>
+                        </a:rPr>
+                        <a:t>Supabase</a:t>
+                      </a:r>
+                      <a:r>
+                        <a:rPr lang="es-CL" sz="1800" kern="1200" dirty="0">
+                          <a:solidFill>
+                            <a:schemeClr val="dk1"/>
+                          </a:solidFill>
+                          <a:latin typeface="+mn-lt"/>
+                          <a:ea typeface="+mn-ea"/>
+                          <a:cs typeface="+mn-cs"/>
+                        </a:rPr>
+                        <a:t> Edge </a:t>
+                      </a:r>
+                      <a:r>
+                        <a:rPr lang="es-CL" sz="1800" kern="1200" dirty="0" err="1">
+                          <a:solidFill>
+                            <a:schemeClr val="dk1"/>
+                          </a:solidFill>
+                          <a:latin typeface="+mn-lt"/>
+                          <a:ea typeface="+mn-ea"/>
+                          <a:cs typeface="+mn-cs"/>
+                        </a:rPr>
+                        <a:t>Function</a:t>
+                      </a:r>
+                      <a:endParaRPr lang="es-CL" sz="1800" kern="1200" dirty="0">
+                        <a:solidFill>
+                          <a:schemeClr val="dk1"/>
+                        </a:solidFill>
+                        <a:latin typeface="+mn-lt"/>
+                        <a:ea typeface="+mn-ea"/>
+                        <a:cs typeface="+mn-cs"/>
+                      </a:endParaRPr>
+                    </a:p>
+                    <a:p>
+                      <a:pPr rtl="0"/>
+                      <a:r>
+                        <a:rPr lang="es-CL" sz="1800" kern="1200" dirty="0">
+                          <a:solidFill>
+                            <a:schemeClr val="dk1"/>
+                          </a:solidFill>
+                          <a:latin typeface="+mn-lt"/>
+                          <a:ea typeface="+mn-ea"/>
+                          <a:cs typeface="+mn-cs"/>
+                        </a:rPr>
+                        <a:t>  │     └── </a:t>
+                      </a:r>
+                      <a:r>
+                        <a:rPr lang="es-CL" sz="1800" kern="1200" dirty="0" err="1">
+                          <a:solidFill>
+                            <a:schemeClr val="dk1"/>
+                          </a:solidFill>
+                          <a:latin typeface="+mn-lt"/>
+                          <a:ea typeface="+mn-ea"/>
+                          <a:cs typeface="+mn-cs"/>
+                        </a:rPr>
+                        <a:t>OpenAI</a:t>
+                      </a:r>
+                      <a:endParaRPr lang="es-CL" sz="1800" kern="1200" dirty="0">
+                        <a:solidFill>
+                          <a:schemeClr val="dk1"/>
+                        </a:solidFill>
+                        <a:latin typeface="+mn-lt"/>
+                        <a:ea typeface="+mn-ea"/>
+                        <a:cs typeface="+mn-cs"/>
+                      </a:endParaRPr>
+                    </a:p>
+                    <a:p>
+                      <a:pPr rtl="0"/>
+                      <a:r>
+                        <a:rPr lang="es-CL" sz="1800" kern="1200" dirty="0">
+                          <a:solidFill>
+                            <a:schemeClr val="dk1"/>
+                          </a:solidFill>
+                          <a:latin typeface="+mn-lt"/>
+                          <a:ea typeface="+mn-ea"/>
+                          <a:cs typeface="+mn-cs"/>
+                        </a:rPr>
+                        <a:t>  ├── Google OAuth</a:t>
+                      </a:r>
+                    </a:p>
+                    <a:p>
+                      <a:pPr rtl="0"/>
+                      <a:r>
+                        <a:rPr lang="es-CL" sz="1800" kern="1200" dirty="0">
+                          <a:solidFill>
+                            <a:schemeClr val="dk1"/>
+                          </a:solidFill>
+                          <a:latin typeface="+mn-lt"/>
+                          <a:ea typeface="+mn-ea"/>
+                          <a:cs typeface="+mn-cs"/>
+                        </a:rPr>
+                        <a:t>  ├── Google Calendar</a:t>
+                      </a:r>
+                    </a:p>
+                    <a:p>
+                      <a:pPr rtl="0"/>
+                      <a:r>
+                        <a:rPr lang="es-CL" sz="1800" kern="1200" dirty="0">
+                          <a:solidFill>
+                            <a:schemeClr val="dk1"/>
+                          </a:solidFill>
+                          <a:latin typeface="+mn-lt"/>
+                          <a:ea typeface="+mn-ea"/>
+                          <a:cs typeface="+mn-cs"/>
+                        </a:rPr>
+                        <a:t>  └── Google Drive</a:t>
+                      </a:r>
+                    </a:p>
+                    <a:p>
+                      <a:endParaRPr lang="es-CL" dirty="0"/>
+                    </a:p>
+                  </a:txBody>
+                  <a:tcPr/>
+                </a:tc>
+                <a:tc>
+                  <a:txBody>
+                    <a:bodyPr/>
+                    <a:lstStyle/>
+                    <a:p>
+                      <a:pPr rtl="0"/>
+                      <a:r>
+                        <a:rPr lang="es-CL" sz="1800" kern="1200" dirty="0" err="1">
+                          <a:solidFill>
+                            <a:schemeClr val="dk1"/>
+                          </a:solidFill>
+                          <a:latin typeface="+mn-lt"/>
+                          <a:ea typeface="+mn-ea"/>
+                          <a:cs typeface="+mn-cs"/>
+                        </a:rPr>
+                        <a:t>React</a:t>
+                      </a:r>
+                      <a:r>
+                        <a:rPr lang="es-CL" sz="1800" kern="1200" dirty="0">
+                          <a:solidFill>
+                            <a:schemeClr val="dk1"/>
+                          </a:solidFill>
+                          <a:latin typeface="+mn-lt"/>
+                          <a:ea typeface="+mn-ea"/>
+                          <a:cs typeface="+mn-cs"/>
+                        </a:rPr>
+                        <a:t> SPA</a:t>
+                      </a:r>
+                    </a:p>
+                    <a:p>
+                      <a:pPr rtl="0"/>
+                      <a:r>
+                        <a:rPr lang="es-CL" sz="1800" kern="1200" dirty="0">
+                          <a:solidFill>
+                            <a:schemeClr val="dk1"/>
+                          </a:solidFill>
+                          <a:latin typeface="+mn-lt"/>
+                          <a:ea typeface="+mn-ea"/>
+                          <a:cs typeface="+mn-cs"/>
+                        </a:rPr>
+                        <a:t>   │</a:t>
+                      </a:r>
+                    </a:p>
+                    <a:p>
+                      <a:pPr rtl="0"/>
+                      <a:r>
+                        <a:rPr lang="es-CL" sz="1800" kern="1200" dirty="0">
+                          <a:solidFill>
+                            <a:schemeClr val="dk1"/>
+                          </a:solidFill>
+                          <a:latin typeface="+mn-lt"/>
+                          <a:ea typeface="+mn-ea"/>
+                          <a:cs typeface="+mn-cs"/>
+                        </a:rPr>
+                        <a:t>   ▼</a:t>
+                      </a:r>
+                    </a:p>
+                    <a:p>
+                      <a:pPr rtl="0"/>
+                      <a:r>
+                        <a:rPr lang="es-CL" sz="1800" kern="1200" dirty="0">
+                          <a:solidFill>
+                            <a:schemeClr val="dk1"/>
+                          </a:solidFill>
+                          <a:latin typeface="+mn-lt"/>
+                          <a:ea typeface="+mn-ea"/>
+                          <a:cs typeface="+mn-cs"/>
+                        </a:rPr>
+                        <a:t>API / Edge </a:t>
+                      </a:r>
+                      <a:r>
+                        <a:rPr lang="es-CL" sz="1800" kern="1200" dirty="0" err="1">
+                          <a:solidFill>
+                            <a:schemeClr val="dk1"/>
+                          </a:solidFill>
+                          <a:latin typeface="+mn-lt"/>
+                          <a:ea typeface="+mn-ea"/>
+                          <a:cs typeface="+mn-cs"/>
+                        </a:rPr>
+                        <a:t>Functions</a:t>
+                      </a:r>
+                      <a:endParaRPr lang="es-CL" sz="1800" kern="1200" dirty="0">
+                        <a:solidFill>
+                          <a:schemeClr val="dk1"/>
+                        </a:solidFill>
+                        <a:latin typeface="+mn-lt"/>
+                        <a:ea typeface="+mn-ea"/>
+                        <a:cs typeface="+mn-cs"/>
+                      </a:endParaRPr>
+                    </a:p>
+                    <a:p>
+                      <a:pPr rtl="0"/>
+                      <a:r>
+                        <a:rPr lang="es-CL" sz="1800" kern="1200" dirty="0">
+                          <a:solidFill>
+                            <a:schemeClr val="dk1"/>
+                          </a:solidFill>
+                          <a:latin typeface="+mn-lt"/>
+                          <a:ea typeface="+mn-ea"/>
+                          <a:cs typeface="+mn-cs"/>
+                        </a:rPr>
+                        <a:t>   │</a:t>
+                      </a:r>
+                    </a:p>
+                    <a:p>
+                      <a:pPr rtl="0"/>
+                      <a:r>
+                        <a:rPr lang="es-CL" sz="1800" kern="1200" dirty="0">
+                          <a:solidFill>
+                            <a:schemeClr val="dk1"/>
+                          </a:solidFill>
+                          <a:latin typeface="+mn-lt"/>
+                          <a:ea typeface="+mn-ea"/>
+                          <a:cs typeface="+mn-cs"/>
+                        </a:rPr>
+                        <a:t>   ├── reglas de negocio</a:t>
+                      </a:r>
+                    </a:p>
+                    <a:p>
+                      <a:pPr rtl="0"/>
+                      <a:r>
+                        <a:rPr lang="es-CL" sz="1800" kern="1200" dirty="0">
+                          <a:solidFill>
+                            <a:schemeClr val="dk1"/>
+                          </a:solidFill>
+                          <a:latin typeface="+mn-lt"/>
+                          <a:ea typeface="+mn-ea"/>
+                          <a:cs typeface="+mn-cs"/>
+                        </a:rPr>
+                        <a:t>   ├── autorización</a:t>
+                      </a:r>
+                    </a:p>
+                    <a:p>
+                      <a:pPr rtl="0"/>
+                      <a:r>
+                        <a:rPr lang="es-CL" sz="1800" kern="1200" dirty="0">
+                          <a:solidFill>
+                            <a:schemeClr val="dk1"/>
+                          </a:solidFill>
+                          <a:latin typeface="+mn-lt"/>
+                          <a:ea typeface="+mn-ea"/>
+                          <a:cs typeface="+mn-cs"/>
+                        </a:rPr>
+                        <a:t>   ├── auditoría</a:t>
+                      </a:r>
+                    </a:p>
+                    <a:p>
+                      <a:pPr rtl="0"/>
+                      <a:r>
+                        <a:rPr lang="es-CL" sz="1800" kern="1200" dirty="0">
+                          <a:solidFill>
+                            <a:schemeClr val="dk1"/>
+                          </a:solidFill>
+                          <a:latin typeface="+mn-lt"/>
+                          <a:ea typeface="+mn-ea"/>
+                          <a:cs typeface="+mn-cs"/>
+                        </a:rPr>
+                        <a:t>   ├── integración Google</a:t>
+                      </a:r>
+                    </a:p>
+                    <a:p>
+                      <a:pPr rtl="0"/>
+                      <a:r>
+                        <a:rPr lang="es-CL" sz="1800" kern="1200" dirty="0">
+                          <a:solidFill>
+                            <a:schemeClr val="dk1"/>
+                          </a:solidFill>
+                          <a:latin typeface="+mn-lt"/>
+                          <a:ea typeface="+mn-ea"/>
+                          <a:cs typeface="+mn-cs"/>
+                        </a:rPr>
+                        <a:t>   └── integración </a:t>
+                      </a:r>
+                      <a:r>
+                        <a:rPr lang="es-CL" sz="1800" kern="1200" dirty="0" err="1">
+                          <a:solidFill>
+                            <a:schemeClr val="dk1"/>
+                          </a:solidFill>
+                          <a:latin typeface="+mn-lt"/>
+                          <a:ea typeface="+mn-ea"/>
+                          <a:cs typeface="+mn-cs"/>
+                        </a:rPr>
+                        <a:t>OpenAI</a:t>
+                      </a:r>
+                      <a:endParaRPr lang="es-CL" sz="1800" kern="1200" dirty="0">
+                        <a:solidFill>
+                          <a:schemeClr val="dk1"/>
+                        </a:solidFill>
+                        <a:latin typeface="+mn-lt"/>
+                        <a:ea typeface="+mn-ea"/>
+                        <a:cs typeface="+mn-cs"/>
+                      </a:endParaRPr>
+                    </a:p>
+                    <a:p>
+                      <a:pPr rtl="0"/>
+                      <a:r>
+                        <a:rPr lang="es-CL" sz="1800" kern="1200" dirty="0">
+                          <a:solidFill>
+                            <a:schemeClr val="dk1"/>
+                          </a:solidFill>
+                          <a:latin typeface="+mn-lt"/>
+                          <a:ea typeface="+mn-ea"/>
+                          <a:cs typeface="+mn-cs"/>
+                        </a:rPr>
+                        <a:t>   │</a:t>
+                      </a:r>
+                    </a:p>
+                    <a:p>
+                      <a:pPr rtl="0"/>
+                      <a:r>
+                        <a:rPr lang="es-CL" sz="1800" kern="1200" dirty="0">
+                          <a:solidFill>
+                            <a:schemeClr val="dk1"/>
+                          </a:solidFill>
+                          <a:latin typeface="+mn-lt"/>
+                          <a:ea typeface="+mn-ea"/>
+                          <a:cs typeface="+mn-cs"/>
+                        </a:rPr>
+                        <a:t>   ▼</a:t>
+                      </a:r>
+                    </a:p>
+                    <a:p>
+                      <a:pPr rtl="0"/>
+                      <a:r>
+                        <a:rPr lang="es-CL" sz="1800" kern="1200" dirty="0">
+                          <a:solidFill>
+                            <a:schemeClr val="dk1"/>
+                          </a:solidFill>
+                          <a:latin typeface="+mn-lt"/>
+                          <a:ea typeface="+mn-ea"/>
+                          <a:cs typeface="+mn-cs"/>
+                        </a:rPr>
+                        <a:t>PostgreSQL + RLS</a:t>
+                      </a:r>
+                    </a:p>
+                    <a:p>
+                      <a:endParaRPr lang="es-CL" dirty="0"/>
+                    </a:p>
+                  </a:txBody>
+                  <a:tcPr/>
+                </a:tc>
+                <a:extLst>
+                  <a:ext uri="{0D108BD9-81ED-4DB2-BD59-A6C34878D82A}">
+                    <a16:rowId xmlns:a16="http://schemas.microsoft.com/office/drawing/2014/main" val="3076206158"/>
+                  </a:ext>
+                </a:extLst>
+              </a:tr>
+            </a:tbl>
+          </a:graphicData>
+        </a:graphic>
+      </p:graphicFrame>
+    </p:spTree>
+    <p:extLst>
+      <p:ext uri="{BB962C8B-B14F-4D97-AF65-F5344CB8AC3E}">
+        <p14:creationId xmlns:p14="http://schemas.microsoft.com/office/powerpoint/2010/main" val="922887325"/>
+      </p:ext>
+    </p:extLst>
+  </p:cSld>
+  <p:clrMapOvr>
+    <a:masterClrMapping/>
+  </p:clrMapOvr>
+</p:sld>
+</file>
+
+<file path=ppt/slides/slide6.xml><?xml version="1.0" encoding="utf-8"?>
+<p:sld xmlns:a="http://schemas.openxmlformats.org/drawingml/2006/main" xmlns:r="http://schemas.openxmlformats.org/officeDocument/2006/relationships" xmlns:p="http://schemas.openxmlformats.org/presentationml/2006/main">
+  <p:cSld>
+    <p:spTree>
+      <p:nvGrpSpPr>
+        <p:cNvPr id="1" name=""/>
+        <p:cNvGrpSpPr/>
+        <p:nvPr/>
+      </p:nvGrpSpPr>
+      <p:grpSpPr>
+        <a:xfrm>
+          <a:off x="0" y="0"/>
+          <a:ext cx="0" cy="0"/>
+          <a:chOff x="0" y="0"/>
+          <a:chExt cx="0" cy="0"/>
+        </a:xfrm>
+      </p:grpSpPr>
+      <p:sp>
+        <p:nvSpPr>
+          <p:cNvPr id="3" name="CuadroTexto 2">
+            <a:extLst>
+              <a:ext uri="{FF2B5EF4-FFF2-40B4-BE49-F238E27FC236}">
+                <a16:creationId xmlns:a16="http://schemas.microsoft.com/office/drawing/2014/main" id="{B72C06E7-573B-B02D-EE99-61E597D9A285}"/>
+              </a:ext>
+            </a:extLst>
+          </p:cNvPr>
+          <p:cNvSpPr txBox="1"/>
+          <p:nvPr/>
+        </p:nvSpPr>
+        <p:spPr>
+          <a:xfrm>
+            <a:off x="3048802" y="1861746"/>
+            <a:ext cx="6097604" cy="3139321"/>
+          </a:xfrm>
+          <a:prstGeom prst="rect">
+            <a:avLst/>
+          </a:prstGeom>
+          <a:noFill/>
+        </p:spPr>
+        <p:txBody>
+          <a:bodyPr wrap="square">
+            <a:spAutoFit/>
+          </a:bodyPr>
+          <a:lstStyle/>
+          <a:p>
+            <a:pPr rtl="0">
+              <a:buNone/>
+            </a:pPr>
+            <a:r>
+              <a:rPr lang="es-CL" dirty="0">
+                <a:latin typeface="Courier New" panose="02070309020205020404" pitchFamily="49" charset="0"/>
+              </a:rPr>
+              <a:t>Arquitectura general:</a:t>
+            </a:r>
+          </a:p>
+          <a:p>
+            <a:pPr rtl="0">
+              <a:buNone/>
+            </a:pPr>
+            <a:r>
+              <a:rPr lang="es-CL" b="1" dirty="0">
+                <a:latin typeface="Courier New" panose="02070309020205020404" pitchFamily="49" charset="0"/>
+              </a:rPr>
+              <a:t>Tres capas</a:t>
+            </a:r>
+          </a:p>
+          <a:p>
+            <a:pPr rtl="0">
+              <a:buNone/>
+            </a:pPr>
+            <a:endParaRPr lang="es-CL" dirty="0">
+              <a:latin typeface="Courier New" panose="02070309020205020404" pitchFamily="49" charset="0"/>
+            </a:endParaRPr>
+          </a:p>
+          <a:p>
+            <a:pPr rtl="0">
+              <a:buNone/>
+            </a:pPr>
+            <a:r>
+              <a:rPr lang="es-CL" dirty="0">
+                <a:latin typeface="Courier New" panose="02070309020205020404" pitchFamily="49" charset="0"/>
+              </a:rPr>
+              <a:t>Organización del negocio:</a:t>
+            </a:r>
+          </a:p>
+          <a:p>
+            <a:pPr rtl="0">
+              <a:buNone/>
+            </a:pPr>
+            <a:r>
+              <a:rPr lang="es-CL" dirty="0">
+                <a:latin typeface="Courier New" panose="02070309020205020404" pitchFamily="49" charset="0"/>
+              </a:rPr>
+              <a:t>Modular y orientada a servicios</a:t>
+            </a:r>
+          </a:p>
+          <a:p>
+            <a:pPr rtl="0">
+              <a:buNone/>
+            </a:pPr>
+            <a:endParaRPr lang="es-CL" dirty="0">
+              <a:latin typeface="Courier New" panose="02070309020205020404" pitchFamily="49" charset="0"/>
+            </a:endParaRPr>
+          </a:p>
+          <a:p>
+            <a:pPr rtl="0">
+              <a:buNone/>
+            </a:pPr>
+            <a:r>
+              <a:rPr lang="es-CL" dirty="0">
+                <a:latin typeface="Courier New" panose="02070309020205020404" pitchFamily="49" charset="0"/>
+              </a:rPr>
+              <a:t>Patrón interno del </a:t>
+            </a:r>
+            <a:r>
+              <a:rPr lang="es-CL" dirty="0" err="1">
+                <a:latin typeface="Courier New" panose="02070309020205020404" pitchFamily="49" charset="0"/>
+              </a:rPr>
+              <a:t>backend</a:t>
+            </a:r>
+            <a:r>
+              <a:rPr lang="es-CL" dirty="0">
+                <a:latin typeface="Courier New" panose="02070309020205020404" pitchFamily="49" charset="0"/>
+              </a:rPr>
+              <a:t>:</a:t>
+            </a:r>
+          </a:p>
+          <a:p>
+            <a:pPr rtl="0">
+              <a:buNone/>
+            </a:pPr>
+            <a:r>
+              <a:rPr lang="es-CL" dirty="0">
+                <a:latin typeface="Courier New" panose="02070309020205020404" pitchFamily="49" charset="0"/>
+              </a:rPr>
+              <a:t>MVC, </a:t>
+            </a:r>
+            <a:r>
+              <a:rPr lang="es-CL" dirty="0" err="1">
+                <a:latin typeface="Courier New" panose="02070309020205020404" pitchFamily="49" charset="0"/>
+              </a:rPr>
+              <a:t>Clean</a:t>
+            </a:r>
+            <a:r>
+              <a:rPr lang="es-CL" dirty="0">
+                <a:latin typeface="Courier New" panose="02070309020205020404" pitchFamily="49" charset="0"/>
+              </a:rPr>
+              <a:t> </a:t>
+            </a:r>
+            <a:r>
+              <a:rPr lang="es-CL" dirty="0" err="1">
+                <a:latin typeface="Courier New" panose="02070309020205020404" pitchFamily="49" charset="0"/>
+              </a:rPr>
+              <a:t>Architecture</a:t>
+            </a:r>
+            <a:r>
+              <a:rPr lang="es-CL" dirty="0">
+                <a:latin typeface="Courier New" panose="02070309020205020404" pitchFamily="49" charset="0"/>
+              </a:rPr>
+              <a:t> o Hexagonal</a:t>
+            </a:r>
+          </a:p>
+          <a:p>
+            <a:pPr rtl="0">
+              <a:buNone/>
+            </a:pPr>
+            <a:endParaRPr lang="es-CL" dirty="0">
+              <a:latin typeface="Courier New" panose="02070309020205020404" pitchFamily="49" charset="0"/>
+            </a:endParaRPr>
+          </a:p>
+          <a:p>
+            <a:pPr rtl="0">
+              <a:buNone/>
+            </a:pPr>
+            <a:r>
+              <a:rPr lang="es-CL" dirty="0" err="1">
+                <a:latin typeface="Courier New" panose="02070309020205020404" pitchFamily="49" charset="0"/>
+              </a:rPr>
+              <a:t>Frontend</a:t>
+            </a:r>
+            <a:r>
+              <a:rPr lang="es-CL" dirty="0">
+                <a:latin typeface="Courier New" panose="02070309020205020404" pitchFamily="49" charset="0"/>
+              </a:rPr>
+              <a:t>:</a:t>
+            </a:r>
+          </a:p>
+          <a:p>
+            <a:pPr rtl="0">
+              <a:buNone/>
+            </a:pPr>
+            <a:r>
+              <a:rPr lang="es-CL" dirty="0" err="1">
+                <a:latin typeface="Courier New" panose="02070309020205020404" pitchFamily="49" charset="0"/>
+              </a:rPr>
+              <a:t>React</a:t>
+            </a:r>
+            <a:r>
+              <a:rPr lang="es-CL" dirty="0">
+                <a:latin typeface="Courier New" panose="02070309020205020404" pitchFamily="49" charset="0"/>
+              </a:rPr>
+              <a:t> basado en componentes</a:t>
+            </a:r>
+          </a:p>
+        </p:txBody>
+      </p:sp>
+    </p:spTree>
+    <p:extLst>
+      <p:ext uri="{BB962C8B-B14F-4D97-AF65-F5344CB8AC3E}">
+        <p14:creationId xmlns:p14="http://schemas.microsoft.com/office/powerpoint/2010/main" val="260186380"/>
+      </p:ext>
+    </p:extLst>
+  </p:cSld>
+  <p:clrMapOvr>
+    <a:masterClrMapping/>
+  </p:clrMapOvr>
+</p:sld>
+</file>
+
+<file path=ppt/slides/slide7.xml><?xml version="1.0" encoding="utf-8"?>
+<p:sld xmlns:a="http://schemas.openxmlformats.org/drawingml/2006/main" xmlns:r="http://schemas.openxmlformats.org/officeDocument/2006/relationships" xmlns:p="http://schemas.openxmlformats.org/presentationml/2006/main">
+  <p:cSld>
+    <p:spTree>
+      <p:nvGrpSpPr>
+        <p:cNvPr id="1" name=""/>
+        <p:cNvGrpSpPr/>
+        <p:nvPr/>
+      </p:nvGrpSpPr>
+      <p:grpSpPr>
+        <a:xfrm>
+          <a:off x="0" y="0"/>
+          <a:ext cx="0" cy="0"/>
+          <a:chOff x="0" y="0"/>
+          <a:chExt cx="0" cy="0"/>
+        </a:xfrm>
+      </p:grpSpPr>
+      <p:pic>
+        <p:nvPicPr>
+          <p:cNvPr id="7" name="Imagen 6">
+            <a:extLst>
+              <a:ext uri="{FF2B5EF4-FFF2-40B4-BE49-F238E27FC236}">
+                <a16:creationId xmlns:a16="http://schemas.microsoft.com/office/drawing/2014/main" id="{4FB8E764-CAB2-9594-1BAA-2B25D60A67D0}"/>
+              </a:ext>
+            </a:extLst>
+          </p:cNvPr>
+          <p:cNvPicPr>
+            <a:picLocks noChangeAspect="1"/>
+          </p:cNvPicPr>
+          <p:nvPr/>
+        </p:nvPicPr>
+        <p:blipFill>
+          <a:blip r:embed="rId2"/>
+          <a:stretch>
+            <a:fillRect/>
+          </a:stretch>
+        </p:blipFill>
+        <p:spPr>
+          <a:xfrm>
+            <a:off x="1794862" y="2004813"/>
+            <a:ext cx="8602275" cy="2848373"/>
+          </a:xfrm>
+          <a:prstGeom prst="rect">
+            <a:avLst/>
+          </a:prstGeom>
+        </p:spPr>
+      </p:pic>
+    </p:spTree>
+    <p:extLst>
+      <p:ext uri="{BB962C8B-B14F-4D97-AF65-F5344CB8AC3E}">
+        <p14:creationId xmlns:p14="http://schemas.microsoft.com/office/powerpoint/2010/main" val="193231249"/>
+      </p:ext>
+    </p:extLst>
   </p:cSld>
   <p:clrMapOvr>
     <a:masterClrMapping/>

</xml_diff>